<commit_message>
Refresh homepage with Paimon-first fictional examples
</commit_message>
<xml_diff>
--- a/examples/aurora-synthetic/output/paimon/aurora-synthetic-paimon-cape-gradient-visual-signature.pptx
+++ b/examples/aurora-synthetic/output/paimon/aurora-synthetic-paimon-cape-gradient-visual-signature.pptx
@@ -2,13 +2,13 @@
 <file path=ppt/presentation.xml><?xml version="1.0" encoding="utf-8"?>
 <p:presentation xmlns:p="http://schemas.openxmlformats.org/presentationml/2006/main">
   <p:sldMasterIdLst>
-    <p:sldMasterId xmlns:r="http://schemas.openxmlformats.org/officeDocument/2006/relationships" id="2147483648" r:id="Re011ae00da4f4de7"/>
+    <p:sldMasterId xmlns:r="http://schemas.openxmlformats.org/officeDocument/2006/relationships" id="2147483648" r:id="R2db928f598154cd7"/>
   </p:sldMasterIdLst>
   <p:notesMasterIdLst>
-    <p:notesMasterId xmlns:r="http://schemas.openxmlformats.org/officeDocument/2006/relationships" r:id="R930c5e51a4554f97"/>
+    <p:notesMasterId xmlns:r="http://schemas.openxmlformats.org/officeDocument/2006/relationships" r:id="R62d9d5d0a4d944ff"/>
   </p:notesMasterIdLst>
   <p:sldIdLst>
-    <p:sldId xmlns:r="http://schemas.openxmlformats.org/officeDocument/2006/relationships" id="256" r:id="R88bba57b0b2e470b"/>
+    <p:sldId xmlns:r="http://schemas.openxmlformats.org/officeDocument/2006/relationships" id="256" r:id="R309f7c5b63664b2e"/>
   </p:sldIdLst>
   <p:sldSz cx="42805350" cy="30279975"/>
   <p:notesSz cx="6858000" cy="9144000"/>
@@ -530,7 +530,7 @@
   </p:cSld>
   <p:clrMap bg1="lt1" tx1="dk1" bg2="lt2" tx2="dk2" accent1="accent1" accent2="accent2" accent3="accent3" accent4="accent4" accent5="accent5" accent6="accent6" hlink="hlink" folHlink="folHlink"/>
   <p:sldLayoutIdLst>
-    <p:sldLayoutId xmlns:r="http://schemas.openxmlformats.org/officeDocument/2006/relationships" id="2147483649" r:id="R8b62d2dd45364861"/>
+    <p:sldLayoutId xmlns:r="http://schemas.openxmlformats.org/officeDocument/2006/relationships" id="2147483649" r:id="R288c98ee5be34cf8"/>
   </p:sldLayoutIdLst>
   <p:txStyles>
     <p:titleStyle>
@@ -1081,7 +1081,7 @@
           <p:cNvPr id="183" name="header-band">
             <a:extLst xmlns:a="http://schemas.openxmlformats.org/drawingml/2006/main">
               <a:ext uri="{FF2B5EF4-FFF2-40B4-BE49-F238E27FC236}">
-                <a16:creationId xmlns:a16="http://schemas.microsoft.com/office/drawing/2014/main" id="{1A5FBB66-7784-4A8D-9E72-0637E8122DAD}"/>
+                <a16:creationId xmlns:a16="http://schemas.microsoft.com/office/drawing/2014/main" id="{2C6AD8DD-AD9A-4A99-8A78-F7E5316751D4}"/>
               </a:ext>
             </a:extLst>
           </p:cNvPr>
@@ -1114,7 +1114,7 @@
           <p:cNvPr id="2" name="top-cape-gradient-1">
             <a:extLst xmlns:a="http://schemas.openxmlformats.org/drawingml/2006/main">
               <a:ext uri="{FF2B5EF4-FFF2-40B4-BE49-F238E27FC236}">
-                <a16:creationId xmlns:a16="http://schemas.microsoft.com/office/drawing/2014/main" id="{6953FC04-A368-4E4A-B4FF-1F92FCB7BAFC}"/>
+                <a16:creationId xmlns:a16="http://schemas.microsoft.com/office/drawing/2014/main" id="{DCB2B0B7-953D-44C9-8086-F32BCCD25332}"/>
               </a:ext>
             </a:extLst>
           </p:cNvPr>
@@ -1147,7 +1147,7 @@
           <p:cNvPr id="3" name="top-cape-gradient-2">
             <a:extLst xmlns:a="http://schemas.openxmlformats.org/drawingml/2006/main">
               <a:ext uri="{FF2B5EF4-FFF2-40B4-BE49-F238E27FC236}">
-                <a16:creationId xmlns:a16="http://schemas.microsoft.com/office/drawing/2014/main" id="{14E5B94B-CDC8-46CD-872A-4B3B7EB83D68}"/>
+                <a16:creationId xmlns:a16="http://schemas.microsoft.com/office/drawing/2014/main" id="{6500E9DB-BE45-49C8-9DA1-95D0CB8C4B65}"/>
               </a:ext>
             </a:extLst>
           </p:cNvPr>
@@ -1180,7 +1180,7 @@
           <p:cNvPr id="4" name="top-cape-gradient-3">
             <a:extLst xmlns:a="http://schemas.openxmlformats.org/drawingml/2006/main">
               <a:ext uri="{FF2B5EF4-FFF2-40B4-BE49-F238E27FC236}">
-                <a16:creationId xmlns:a16="http://schemas.microsoft.com/office/drawing/2014/main" id="{822406BE-8E8D-4B7E-94CE-E4DFD48EF62D}"/>
+                <a16:creationId xmlns:a16="http://schemas.microsoft.com/office/drawing/2014/main" id="{56CC57ED-ED7B-486D-A2AA-CD85A77A647A}"/>
               </a:ext>
             </a:extLst>
           </p:cNvPr>
@@ -1213,7 +1213,7 @@
           <p:cNvPr id="5" name="top-cape-gradient-4">
             <a:extLst xmlns:a="http://schemas.openxmlformats.org/drawingml/2006/main">
               <a:ext uri="{FF2B5EF4-FFF2-40B4-BE49-F238E27FC236}">
-                <a16:creationId xmlns:a16="http://schemas.microsoft.com/office/drawing/2014/main" id="{428C3A5D-977D-4307-A9A3-F0D58EAB12AC}"/>
+                <a16:creationId xmlns:a16="http://schemas.microsoft.com/office/drawing/2014/main" id="{C86E07C8-80D0-4126-B2EE-6EADFCBB45FF}"/>
               </a:ext>
             </a:extLst>
           </p:cNvPr>
@@ -1246,7 +1246,7 @@
           <p:cNvPr id="6" name="top-cape-gradient-5">
             <a:extLst xmlns:a="http://schemas.openxmlformats.org/drawingml/2006/main">
               <a:ext uri="{FF2B5EF4-FFF2-40B4-BE49-F238E27FC236}">
-                <a16:creationId xmlns:a16="http://schemas.microsoft.com/office/drawing/2014/main" id="{7B3461D1-0E69-4E6F-9055-C8277A5651E9}"/>
+                <a16:creationId xmlns:a16="http://schemas.microsoft.com/office/drawing/2014/main" id="{6ADF09AA-CE4B-4527-B79C-DFAECEA0EEA8}"/>
               </a:ext>
             </a:extLst>
           </p:cNvPr>
@@ -1279,7 +1279,7 @@
           <p:cNvPr id="7" name="top-cape-gradient-6">
             <a:extLst xmlns:a="http://schemas.openxmlformats.org/drawingml/2006/main">
               <a:ext uri="{FF2B5EF4-FFF2-40B4-BE49-F238E27FC236}">
-                <a16:creationId xmlns:a16="http://schemas.microsoft.com/office/drawing/2014/main" id="{84B0CFCA-CB43-434D-AD7C-1484487727E8}"/>
+                <a16:creationId xmlns:a16="http://schemas.microsoft.com/office/drawing/2014/main" id="{05CB6540-3518-48C1-A020-A87656EE691F}"/>
               </a:ext>
             </a:extLst>
           </p:cNvPr>
@@ -1312,7 +1312,7 @@
           <p:cNvPr id="8" name="top-cape-gradient-7">
             <a:extLst xmlns:a="http://schemas.openxmlformats.org/drawingml/2006/main">
               <a:ext uri="{FF2B5EF4-FFF2-40B4-BE49-F238E27FC236}">
-                <a16:creationId xmlns:a16="http://schemas.microsoft.com/office/drawing/2014/main" id="{3810274B-3042-4452-93C6-F9143C50E050}"/>
+                <a16:creationId xmlns:a16="http://schemas.microsoft.com/office/drawing/2014/main" id="{446E1D4A-F8B9-4235-A37B-F43BDD483F8B}"/>
               </a:ext>
             </a:extLst>
           </p:cNvPr>
@@ -1345,7 +1345,7 @@
           <p:cNvPr id="9" name="top-cape-gradient-8">
             <a:extLst xmlns:a="http://schemas.openxmlformats.org/drawingml/2006/main">
               <a:ext uri="{FF2B5EF4-FFF2-40B4-BE49-F238E27FC236}">
-                <a16:creationId xmlns:a16="http://schemas.microsoft.com/office/drawing/2014/main" id="{1A3CBD02-2A9C-4303-B6EE-D711499FC81C}"/>
+                <a16:creationId xmlns:a16="http://schemas.microsoft.com/office/drawing/2014/main" id="{E347EBD7-8999-4509-80AA-E722C929062E}"/>
               </a:ext>
             </a:extLst>
           </p:cNvPr>
@@ -1378,7 +1378,7 @@
           <p:cNvPr id="10" name="top-cape-gradient-9">
             <a:extLst xmlns:a="http://schemas.openxmlformats.org/drawingml/2006/main">
               <a:ext uri="{FF2B5EF4-FFF2-40B4-BE49-F238E27FC236}">
-                <a16:creationId xmlns:a16="http://schemas.microsoft.com/office/drawing/2014/main" id="{E66DBF87-C48D-4796-8BF7-480B52E16DAC}"/>
+                <a16:creationId xmlns:a16="http://schemas.microsoft.com/office/drawing/2014/main" id="{B7BE8A34-EA70-4D52-A10D-1F06F045FB5C}"/>
               </a:ext>
             </a:extLst>
           </p:cNvPr>
@@ -1411,7 +1411,7 @@
           <p:cNvPr id="11" name="top-cape-gradient-10">
             <a:extLst xmlns:a="http://schemas.openxmlformats.org/drawingml/2006/main">
               <a:ext uri="{FF2B5EF4-FFF2-40B4-BE49-F238E27FC236}">
-                <a16:creationId xmlns:a16="http://schemas.microsoft.com/office/drawing/2014/main" id="{8F59EEF5-31F8-4D2F-B5DB-83B8BABF25F5}"/>
+                <a16:creationId xmlns:a16="http://schemas.microsoft.com/office/drawing/2014/main" id="{2E9081B5-497E-42AE-A834-27D4A883A18C}"/>
               </a:ext>
             </a:extLst>
           </p:cNvPr>
@@ -1444,7 +1444,7 @@
           <p:cNvPr id="12" name="top-cape-gradient-11">
             <a:extLst xmlns:a="http://schemas.openxmlformats.org/drawingml/2006/main">
               <a:ext uri="{FF2B5EF4-FFF2-40B4-BE49-F238E27FC236}">
-                <a16:creationId xmlns:a16="http://schemas.microsoft.com/office/drawing/2014/main" id="{B3C4D0EB-84DC-47B7-AE69-E26AB6C82CAC}"/>
+                <a16:creationId xmlns:a16="http://schemas.microsoft.com/office/drawing/2014/main" id="{9EC1A315-B02A-4992-8257-2C5FB4227525}"/>
               </a:ext>
             </a:extLst>
           </p:cNvPr>
@@ -1477,7 +1477,7 @@
           <p:cNvPr id="13" name="top-cape-gradient-12">
             <a:extLst xmlns:a="http://schemas.openxmlformats.org/drawingml/2006/main">
               <a:ext uri="{FF2B5EF4-FFF2-40B4-BE49-F238E27FC236}">
-                <a16:creationId xmlns:a16="http://schemas.microsoft.com/office/drawing/2014/main" id="{53E20C83-575C-4156-A0E3-FF219377179F}"/>
+                <a16:creationId xmlns:a16="http://schemas.microsoft.com/office/drawing/2014/main" id="{F58A94EE-9C1F-4DF0-8CE9-7C77CEB4A83A}"/>
               </a:ext>
             </a:extLst>
           </p:cNvPr>
@@ -1510,7 +1510,7 @@
           <p:cNvPr id="14" name="top-cape-gradient-13">
             <a:extLst xmlns:a="http://schemas.openxmlformats.org/drawingml/2006/main">
               <a:ext uri="{FF2B5EF4-FFF2-40B4-BE49-F238E27FC236}">
-                <a16:creationId xmlns:a16="http://schemas.microsoft.com/office/drawing/2014/main" id="{C2947336-FAA2-45EA-9B75-01A7AF535059}"/>
+                <a16:creationId xmlns:a16="http://schemas.microsoft.com/office/drawing/2014/main" id="{AF04112B-FEF4-4416-966F-58A1305A9147}"/>
               </a:ext>
             </a:extLst>
           </p:cNvPr>
@@ -1543,7 +1543,7 @@
           <p:cNvPr id="15" name="top-cape-gradient-14">
             <a:extLst xmlns:a="http://schemas.openxmlformats.org/drawingml/2006/main">
               <a:ext uri="{FF2B5EF4-FFF2-40B4-BE49-F238E27FC236}">
-                <a16:creationId xmlns:a16="http://schemas.microsoft.com/office/drawing/2014/main" id="{4AE8858C-B51B-424D-B321-DEFB746BF4D3}"/>
+                <a16:creationId xmlns:a16="http://schemas.microsoft.com/office/drawing/2014/main" id="{C377BF34-D433-4368-B23B-9C8CD95EE4D3}"/>
               </a:ext>
             </a:extLst>
           </p:cNvPr>
@@ -1576,7 +1576,7 @@
           <p:cNvPr id="16" name="top-cape-gradient-15">
             <a:extLst xmlns:a="http://schemas.openxmlformats.org/drawingml/2006/main">
               <a:ext uri="{FF2B5EF4-FFF2-40B4-BE49-F238E27FC236}">
-                <a16:creationId xmlns:a16="http://schemas.microsoft.com/office/drawing/2014/main" id="{A49124CE-FD55-4E55-BA6A-8C2264E3B443}"/>
+                <a16:creationId xmlns:a16="http://schemas.microsoft.com/office/drawing/2014/main" id="{2B1F10AD-E855-4D4B-B6B5-90840159F2AC}"/>
               </a:ext>
             </a:extLst>
           </p:cNvPr>
@@ -1609,7 +1609,7 @@
           <p:cNvPr id="17" name="top-cape-gradient-16">
             <a:extLst xmlns:a="http://schemas.openxmlformats.org/drawingml/2006/main">
               <a:ext uri="{FF2B5EF4-FFF2-40B4-BE49-F238E27FC236}">
-                <a16:creationId xmlns:a16="http://schemas.microsoft.com/office/drawing/2014/main" id="{95643686-A37F-4488-AD72-4833C8A1BE17}"/>
+                <a16:creationId xmlns:a16="http://schemas.microsoft.com/office/drawing/2014/main" id="{0E8B475A-4F78-4EAF-8ED1-7204CE58E7E8}"/>
               </a:ext>
             </a:extLst>
           </p:cNvPr>
@@ -1642,7 +1642,7 @@
           <p:cNvPr id="18" name="top-cape-gradient-17">
             <a:extLst xmlns:a="http://schemas.openxmlformats.org/drawingml/2006/main">
               <a:ext uri="{FF2B5EF4-FFF2-40B4-BE49-F238E27FC236}">
-                <a16:creationId xmlns:a16="http://schemas.microsoft.com/office/drawing/2014/main" id="{3926EC74-0916-4974-AAA9-CE0FD105D008}"/>
+                <a16:creationId xmlns:a16="http://schemas.microsoft.com/office/drawing/2014/main" id="{F046F4EB-0332-47F4-AC21-D7E00C599D8D}"/>
               </a:ext>
             </a:extLst>
           </p:cNvPr>
@@ -1675,7 +1675,7 @@
           <p:cNvPr id="19" name="top-cape-gradient-18">
             <a:extLst xmlns:a="http://schemas.openxmlformats.org/drawingml/2006/main">
               <a:ext uri="{FF2B5EF4-FFF2-40B4-BE49-F238E27FC236}">
-                <a16:creationId xmlns:a16="http://schemas.microsoft.com/office/drawing/2014/main" id="{4046E9E0-3FAF-4BD5-A135-574372CFE812}"/>
+                <a16:creationId xmlns:a16="http://schemas.microsoft.com/office/drawing/2014/main" id="{C8C55C2E-99F1-4AE6-83B7-20A8416998A3}"/>
               </a:ext>
             </a:extLst>
           </p:cNvPr>
@@ -1708,7 +1708,7 @@
           <p:cNvPr id="20" name="top-cape-gradient-19">
             <a:extLst xmlns:a="http://schemas.openxmlformats.org/drawingml/2006/main">
               <a:ext uri="{FF2B5EF4-FFF2-40B4-BE49-F238E27FC236}">
-                <a16:creationId xmlns:a16="http://schemas.microsoft.com/office/drawing/2014/main" id="{C92029F3-8B27-4AA2-8FC6-BC37C8545D59}"/>
+                <a16:creationId xmlns:a16="http://schemas.microsoft.com/office/drawing/2014/main" id="{172B05CB-AE33-45BF-B55A-CDA434E1015C}"/>
               </a:ext>
             </a:extLst>
           </p:cNvPr>
@@ -1741,7 +1741,7 @@
           <p:cNvPr id="21" name="top-cape-gradient-20">
             <a:extLst xmlns:a="http://schemas.openxmlformats.org/drawingml/2006/main">
               <a:ext uri="{FF2B5EF4-FFF2-40B4-BE49-F238E27FC236}">
-                <a16:creationId xmlns:a16="http://schemas.microsoft.com/office/drawing/2014/main" id="{77577F32-6C13-496D-B3C0-F86421548D31}"/>
+                <a16:creationId xmlns:a16="http://schemas.microsoft.com/office/drawing/2014/main" id="{FE8E4841-8255-48D3-B02B-CF81A2613CAC}"/>
               </a:ext>
             </a:extLst>
           </p:cNvPr>
@@ -1774,7 +1774,7 @@
           <p:cNvPr id="22" name="top-cape-gradient-21">
             <a:extLst xmlns:a="http://schemas.openxmlformats.org/drawingml/2006/main">
               <a:ext uri="{FF2B5EF4-FFF2-40B4-BE49-F238E27FC236}">
-                <a16:creationId xmlns:a16="http://schemas.microsoft.com/office/drawing/2014/main" id="{FB6DC64D-03A0-4745-8A74-03BBB299481A}"/>
+                <a16:creationId xmlns:a16="http://schemas.microsoft.com/office/drawing/2014/main" id="{E4DDA296-85D5-40E3-B69D-73D5212AC4ED}"/>
               </a:ext>
             </a:extLst>
           </p:cNvPr>
@@ -1807,7 +1807,7 @@
           <p:cNvPr id="23" name="top-cape-gradient-22">
             <a:extLst xmlns:a="http://schemas.openxmlformats.org/drawingml/2006/main">
               <a:ext uri="{FF2B5EF4-FFF2-40B4-BE49-F238E27FC236}">
-                <a16:creationId xmlns:a16="http://schemas.microsoft.com/office/drawing/2014/main" id="{7364D6EC-9D78-4F96-AD2E-CC7E4AE0A694}"/>
+                <a16:creationId xmlns:a16="http://schemas.microsoft.com/office/drawing/2014/main" id="{CC2EF868-568D-4537-ADDC-3614A18C6FDB}"/>
               </a:ext>
             </a:extLst>
           </p:cNvPr>
@@ -1840,7 +1840,7 @@
           <p:cNvPr id="24" name="top-cape-gradient-23">
             <a:extLst xmlns:a="http://schemas.openxmlformats.org/drawingml/2006/main">
               <a:ext uri="{FF2B5EF4-FFF2-40B4-BE49-F238E27FC236}">
-                <a16:creationId xmlns:a16="http://schemas.microsoft.com/office/drawing/2014/main" id="{C1252DD8-8436-46A2-A7DE-766B25E2A32B}"/>
+                <a16:creationId xmlns:a16="http://schemas.microsoft.com/office/drawing/2014/main" id="{217AE96C-DB36-45C0-B134-B62B4F7DA420}"/>
               </a:ext>
             </a:extLst>
           </p:cNvPr>
@@ -1873,7 +1873,7 @@
           <p:cNvPr id="25" name="top-cape-gradient-24">
             <a:extLst xmlns:a="http://schemas.openxmlformats.org/drawingml/2006/main">
               <a:ext uri="{FF2B5EF4-FFF2-40B4-BE49-F238E27FC236}">
-                <a16:creationId xmlns:a16="http://schemas.microsoft.com/office/drawing/2014/main" id="{DA187712-BB0F-4518-9818-A09EF3D68775}"/>
+                <a16:creationId xmlns:a16="http://schemas.microsoft.com/office/drawing/2014/main" id="{65CC7CB3-04BF-4AF6-8EB6-904EDB5C8049}"/>
               </a:ext>
             </a:extLst>
           </p:cNvPr>
@@ -1906,7 +1906,7 @@
           <p:cNvPr id="26" name="top-cape-gradient-25">
             <a:extLst xmlns:a="http://schemas.openxmlformats.org/drawingml/2006/main">
               <a:ext uri="{FF2B5EF4-FFF2-40B4-BE49-F238E27FC236}">
-                <a16:creationId xmlns:a16="http://schemas.microsoft.com/office/drawing/2014/main" id="{27F97747-A387-4C92-9EDA-9E7CB21DD1EE}"/>
+                <a16:creationId xmlns:a16="http://schemas.microsoft.com/office/drawing/2014/main" id="{BED18F81-1456-4A68-8535-F0FE286B9973}"/>
               </a:ext>
             </a:extLst>
           </p:cNvPr>
@@ -1939,7 +1939,7 @@
           <p:cNvPr id="27" name="top-cape-gradient-26">
             <a:extLst xmlns:a="http://schemas.openxmlformats.org/drawingml/2006/main">
               <a:ext uri="{FF2B5EF4-FFF2-40B4-BE49-F238E27FC236}">
-                <a16:creationId xmlns:a16="http://schemas.microsoft.com/office/drawing/2014/main" id="{7DD22AE5-BEDC-4E3F-933C-B5088DA24EC8}"/>
+                <a16:creationId xmlns:a16="http://schemas.microsoft.com/office/drawing/2014/main" id="{22F12C33-C370-4B6F-A0AA-36354660A0BA}"/>
               </a:ext>
             </a:extLst>
           </p:cNvPr>
@@ -1972,7 +1972,7 @@
           <p:cNvPr id="28" name="top-cape-gradient-27">
             <a:extLst xmlns:a="http://schemas.openxmlformats.org/drawingml/2006/main">
               <a:ext uri="{FF2B5EF4-FFF2-40B4-BE49-F238E27FC236}">
-                <a16:creationId xmlns:a16="http://schemas.microsoft.com/office/drawing/2014/main" id="{8D4C9160-879A-482B-BA81-10147930595C}"/>
+                <a16:creationId xmlns:a16="http://schemas.microsoft.com/office/drawing/2014/main" id="{285F680B-B4CF-4AD6-9BA2-08D1E9A1E7E8}"/>
               </a:ext>
             </a:extLst>
           </p:cNvPr>
@@ -2005,7 +2005,7 @@
           <p:cNvPr id="29" name="top-cape-gradient-28">
             <a:extLst xmlns:a="http://schemas.openxmlformats.org/drawingml/2006/main">
               <a:ext uri="{FF2B5EF4-FFF2-40B4-BE49-F238E27FC236}">
-                <a16:creationId xmlns:a16="http://schemas.microsoft.com/office/drawing/2014/main" id="{D107A68A-26F7-400D-9647-97139D6ACDE6}"/>
+                <a16:creationId xmlns:a16="http://schemas.microsoft.com/office/drawing/2014/main" id="{45641ED7-74DB-44EA-8E8F-04F286C93B14}"/>
               </a:ext>
             </a:extLst>
           </p:cNvPr>
@@ -2038,7 +2038,7 @@
           <p:cNvPr id="30" name="top-cape-gradient-29">
             <a:extLst xmlns:a="http://schemas.openxmlformats.org/drawingml/2006/main">
               <a:ext uri="{FF2B5EF4-FFF2-40B4-BE49-F238E27FC236}">
-                <a16:creationId xmlns:a16="http://schemas.microsoft.com/office/drawing/2014/main" id="{6BF17DA7-F928-4961-8E15-CF839C8AE817}"/>
+                <a16:creationId xmlns:a16="http://schemas.microsoft.com/office/drawing/2014/main" id="{E41ACED1-19BB-4619-88D1-AD980C8EC823}"/>
               </a:ext>
             </a:extLst>
           </p:cNvPr>
@@ -2071,7 +2071,7 @@
           <p:cNvPr id="31" name="top-cape-gradient-30">
             <a:extLst xmlns:a="http://schemas.openxmlformats.org/drawingml/2006/main">
               <a:ext uri="{FF2B5EF4-FFF2-40B4-BE49-F238E27FC236}">
-                <a16:creationId xmlns:a16="http://schemas.microsoft.com/office/drawing/2014/main" id="{D0156F4F-8B98-44CC-9E2E-188092A458C0}"/>
+                <a16:creationId xmlns:a16="http://schemas.microsoft.com/office/drawing/2014/main" id="{CE4028EF-8339-4DB2-9389-B77A28ACF122}"/>
               </a:ext>
             </a:extLst>
           </p:cNvPr>
@@ -2104,7 +2104,7 @@
           <p:cNvPr id="32" name="top-cape-gradient-31">
             <a:extLst xmlns:a="http://schemas.openxmlformats.org/drawingml/2006/main">
               <a:ext uri="{FF2B5EF4-FFF2-40B4-BE49-F238E27FC236}">
-                <a16:creationId xmlns:a16="http://schemas.microsoft.com/office/drawing/2014/main" id="{ACE0A31A-2C1E-49F7-81A6-8FEF410B36F0}"/>
+                <a16:creationId xmlns:a16="http://schemas.microsoft.com/office/drawing/2014/main" id="{06D9E5B4-3433-42F8-87A8-7242094C8D46}"/>
               </a:ext>
             </a:extLst>
           </p:cNvPr>
@@ -2137,7 +2137,7 @@
           <p:cNvPr id="33" name="top-cape-gradient-32">
             <a:extLst xmlns:a="http://schemas.openxmlformats.org/drawingml/2006/main">
               <a:ext uri="{FF2B5EF4-FFF2-40B4-BE49-F238E27FC236}">
-                <a16:creationId xmlns:a16="http://schemas.microsoft.com/office/drawing/2014/main" id="{95D6CBA9-0B1E-4A33-8E30-94DB5B8FE295}"/>
+                <a16:creationId xmlns:a16="http://schemas.microsoft.com/office/drawing/2014/main" id="{E9E870EC-662D-450D-9C9E-AAC53464EB41}"/>
               </a:ext>
             </a:extLst>
           </p:cNvPr>
@@ -2170,7 +2170,7 @@
           <p:cNvPr id="34" name="header-cape-gradient-1">
             <a:extLst xmlns:a="http://schemas.openxmlformats.org/drawingml/2006/main">
               <a:ext uri="{FF2B5EF4-FFF2-40B4-BE49-F238E27FC236}">
-                <a16:creationId xmlns:a16="http://schemas.microsoft.com/office/drawing/2014/main" id="{76568BA0-E7C0-4955-8B4E-FB7A6FBA9981}"/>
+                <a16:creationId xmlns:a16="http://schemas.microsoft.com/office/drawing/2014/main" id="{7B2D8CF4-CE8E-4F15-BA25-7DEB55F1E761}"/>
               </a:ext>
             </a:extLst>
           </p:cNvPr>
@@ -2203,7 +2203,7 @@
           <p:cNvPr id="35" name="header-cape-gradient-2">
             <a:extLst xmlns:a="http://schemas.openxmlformats.org/drawingml/2006/main">
               <a:ext uri="{FF2B5EF4-FFF2-40B4-BE49-F238E27FC236}">
-                <a16:creationId xmlns:a16="http://schemas.microsoft.com/office/drawing/2014/main" id="{BB1BB8E2-0EAA-4703-8D3D-DF23129A1C7B}"/>
+                <a16:creationId xmlns:a16="http://schemas.microsoft.com/office/drawing/2014/main" id="{D00ECC70-61BA-4E36-86EA-3D482A75FD90}"/>
               </a:ext>
             </a:extLst>
           </p:cNvPr>
@@ -2236,7 +2236,7 @@
           <p:cNvPr id="36" name="header-cape-gradient-3">
             <a:extLst xmlns:a="http://schemas.openxmlformats.org/drawingml/2006/main">
               <a:ext uri="{FF2B5EF4-FFF2-40B4-BE49-F238E27FC236}">
-                <a16:creationId xmlns:a16="http://schemas.microsoft.com/office/drawing/2014/main" id="{C5D28011-51C5-49FC-BAF6-7F4CF7919FA1}"/>
+                <a16:creationId xmlns:a16="http://schemas.microsoft.com/office/drawing/2014/main" id="{4D51871C-241E-43BE-A432-4A6A76174DF6}"/>
               </a:ext>
             </a:extLst>
           </p:cNvPr>
@@ -2269,7 +2269,7 @@
           <p:cNvPr id="37" name="header-cape-gradient-4">
             <a:extLst xmlns:a="http://schemas.openxmlformats.org/drawingml/2006/main">
               <a:ext uri="{FF2B5EF4-FFF2-40B4-BE49-F238E27FC236}">
-                <a16:creationId xmlns:a16="http://schemas.microsoft.com/office/drawing/2014/main" id="{60F9C4D6-DEF6-4084-B5A9-FD124D35E111}"/>
+                <a16:creationId xmlns:a16="http://schemas.microsoft.com/office/drawing/2014/main" id="{2AAB61A7-A4A0-487E-8E3A-5B8B026E61E5}"/>
               </a:ext>
             </a:extLst>
           </p:cNvPr>
@@ -2302,7 +2302,7 @@
           <p:cNvPr id="38" name="header-cape-gradient-5">
             <a:extLst xmlns:a="http://schemas.openxmlformats.org/drawingml/2006/main">
               <a:ext uri="{FF2B5EF4-FFF2-40B4-BE49-F238E27FC236}">
-                <a16:creationId xmlns:a16="http://schemas.microsoft.com/office/drawing/2014/main" id="{FD306699-2D9F-4F15-AD64-6C81F4B29DE5}"/>
+                <a16:creationId xmlns:a16="http://schemas.microsoft.com/office/drawing/2014/main" id="{77E3CF99-2855-4276-A2E3-7EABA8C409ED}"/>
               </a:ext>
             </a:extLst>
           </p:cNvPr>
@@ -2335,7 +2335,7 @@
           <p:cNvPr id="39" name="header-cape-gradient-6">
             <a:extLst xmlns:a="http://schemas.openxmlformats.org/drawingml/2006/main">
               <a:ext uri="{FF2B5EF4-FFF2-40B4-BE49-F238E27FC236}">
-                <a16:creationId xmlns:a16="http://schemas.microsoft.com/office/drawing/2014/main" id="{6BA3D00A-E473-4340-B13B-6D65607B443C}"/>
+                <a16:creationId xmlns:a16="http://schemas.microsoft.com/office/drawing/2014/main" id="{984F7679-CD0A-4E71-9DCF-A50E253C3730}"/>
               </a:ext>
             </a:extLst>
           </p:cNvPr>
@@ -2368,7 +2368,7 @@
           <p:cNvPr id="40" name="header-cape-gradient-7">
             <a:extLst xmlns:a="http://schemas.openxmlformats.org/drawingml/2006/main">
               <a:ext uri="{FF2B5EF4-FFF2-40B4-BE49-F238E27FC236}">
-                <a16:creationId xmlns:a16="http://schemas.microsoft.com/office/drawing/2014/main" id="{C3EE2A3C-7BEB-4A5A-B6AE-F4F0D6D3B508}"/>
+                <a16:creationId xmlns:a16="http://schemas.microsoft.com/office/drawing/2014/main" id="{72A8FA59-64EF-4F6F-8A89-BB9E4CFC113C}"/>
               </a:ext>
             </a:extLst>
           </p:cNvPr>
@@ -2401,7 +2401,7 @@
           <p:cNvPr id="41" name="header-cape-gradient-8">
             <a:extLst xmlns:a="http://schemas.openxmlformats.org/drawingml/2006/main">
               <a:ext uri="{FF2B5EF4-FFF2-40B4-BE49-F238E27FC236}">
-                <a16:creationId xmlns:a16="http://schemas.microsoft.com/office/drawing/2014/main" id="{06BB1947-3364-4B70-BB04-F74936072CEB}"/>
+                <a16:creationId xmlns:a16="http://schemas.microsoft.com/office/drawing/2014/main" id="{853CCEB3-D8EF-469E-89B0-B9CEF0725738}"/>
               </a:ext>
             </a:extLst>
           </p:cNvPr>
@@ -2434,7 +2434,7 @@
           <p:cNvPr id="42" name="header-cape-gradient-9">
             <a:extLst xmlns:a="http://schemas.openxmlformats.org/drawingml/2006/main">
               <a:ext uri="{FF2B5EF4-FFF2-40B4-BE49-F238E27FC236}">
-                <a16:creationId xmlns:a16="http://schemas.microsoft.com/office/drawing/2014/main" id="{E778593E-EF5B-4C29-9D8B-6BF486378B94}"/>
+                <a16:creationId xmlns:a16="http://schemas.microsoft.com/office/drawing/2014/main" id="{46D6BA0B-D06E-4790-B50B-020C3F8F9AFB}"/>
               </a:ext>
             </a:extLst>
           </p:cNvPr>
@@ -2467,7 +2467,7 @@
           <p:cNvPr id="43" name="header-cape-gradient-10">
             <a:extLst xmlns:a="http://schemas.openxmlformats.org/drawingml/2006/main">
               <a:ext uri="{FF2B5EF4-FFF2-40B4-BE49-F238E27FC236}">
-                <a16:creationId xmlns:a16="http://schemas.microsoft.com/office/drawing/2014/main" id="{E51B4314-2741-4D74-93B4-D93C924D6254}"/>
+                <a16:creationId xmlns:a16="http://schemas.microsoft.com/office/drawing/2014/main" id="{39FF363F-D826-4A89-B39F-3C9FC9784E39}"/>
               </a:ext>
             </a:extLst>
           </p:cNvPr>
@@ -2500,7 +2500,7 @@
           <p:cNvPr id="44" name="header-cape-gradient-11">
             <a:extLst xmlns:a="http://schemas.openxmlformats.org/drawingml/2006/main">
               <a:ext uri="{FF2B5EF4-FFF2-40B4-BE49-F238E27FC236}">
-                <a16:creationId xmlns:a16="http://schemas.microsoft.com/office/drawing/2014/main" id="{6F2E2A98-5BFC-4C8A-8114-3329C17302D6}"/>
+                <a16:creationId xmlns:a16="http://schemas.microsoft.com/office/drawing/2014/main" id="{C1FC0E99-CDF5-4A59-B369-32BBD153E5BD}"/>
               </a:ext>
             </a:extLst>
           </p:cNvPr>
@@ -2533,7 +2533,7 @@
           <p:cNvPr id="45" name="header-cape-gradient-12">
             <a:extLst xmlns:a="http://schemas.openxmlformats.org/drawingml/2006/main">
               <a:ext uri="{FF2B5EF4-FFF2-40B4-BE49-F238E27FC236}">
-                <a16:creationId xmlns:a16="http://schemas.microsoft.com/office/drawing/2014/main" id="{8E6E63C3-FEC9-47B1-9AB2-643A4F38C516}"/>
+                <a16:creationId xmlns:a16="http://schemas.microsoft.com/office/drawing/2014/main" id="{6B7507AD-7D88-4622-BA8E-36F71F5D4804}"/>
               </a:ext>
             </a:extLst>
           </p:cNvPr>
@@ -2566,7 +2566,7 @@
           <p:cNvPr id="46" name="header-cape-gradient-13">
             <a:extLst xmlns:a="http://schemas.openxmlformats.org/drawingml/2006/main">
               <a:ext uri="{FF2B5EF4-FFF2-40B4-BE49-F238E27FC236}">
-                <a16:creationId xmlns:a16="http://schemas.microsoft.com/office/drawing/2014/main" id="{DECB3A82-3634-4E1B-9B50-7C6688058413}"/>
+                <a16:creationId xmlns:a16="http://schemas.microsoft.com/office/drawing/2014/main" id="{DD4A23A6-2DFA-4726-8C81-B5B9AA33E97E}"/>
               </a:ext>
             </a:extLst>
           </p:cNvPr>
@@ -2599,7 +2599,7 @@
           <p:cNvPr id="47" name="header-cape-gradient-14">
             <a:extLst xmlns:a="http://schemas.openxmlformats.org/drawingml/2006/main">
               <a:ext uri="{FF2B5EF4-FFF2-40B4-BE49-F238E27FC236}">
-                <a16:creationId xmlns:a16="http://schemas.microsoft.com/office/drawing/2014/main" id="{5C4C13DD-9E6C-4DC5-BFDE-AFC4F532A179}"/>
+                <a16:creationId xmlns:a16="http://schemas.microsoft.com/office/drawing/2014/main" id="{EC231D7D-A4D4-46E1-969F-6C857C7E5122}"/>
               </a:ext>
             </a:extLst>
           </p:cNvPr>
@@ -2632,7 +2632,7 @@
           <p:cNvPr id="48" name="header-cape-gradient-15">
             <a:extLst xmlns:a="http://schemas.openxmlformats.org/drawingml/2006/main">
               <a:ext uri="{FF2B5EF4-FFF2-40B4-BE49-F238E27FC236}">
-                <a16:creationId xmlns:a16="http://schemas.microsoft.com/office/drawing/2014/main" id="{8B9CECC7-6537-45D2-A8D5-A9258F52CF18}"/>
+                <a16:creationId xmlns:a16="http://schemas.microsoft.com/office/drawing/2014/main" id="{A517E9B1-8F9E-45B1-92BA-CBF64144099C}"/>
               </a:ext>
             </a:extLst>
           </p:cNvPr>
@@ -2665,7 +2665,7 @@
           <p:cNvPr id="49" name="header-cape-gradient-16">
             <a:extLst xmlns:a="http://schemas.openxmlformats.org/drawingml/2006/main">
               <a:ext uri="{FF2B5EF4-FFF2-40B4-BE49-F238E27FC236}">
-                <a16:creationId xmlns:a16="http://schemas.microsoft.com/office/drawing/2014/main" id="{66EBDA19-7487-415E-9657-C888160B34BC}"/>
+                <a16:creationId xmlns:a16="http://schemas.microsoft.com/office/drawing/2014/main" id="{5D9EA838-D834-4A80-B864-B458EE244F46}"/>
               </a:ext>
             </a:extLst>
           </p:cNvPr>
@@ -2698,7 +2698,7 @@
           <p:cNvPr id="50" name="header-cape-gradient-17">
             <a:extLst xmlns:a="http://schemas.openxmlformats.org/drawingml/2006/main">
               <a:ext uri="{FF2B5EF4-FFF2-40B4-BE49-F238E27FC236}">
-                <a16:creationId xmlns:a16="http://schemas.microsoft.com/office/drawing/2014/main" id="{4E9BF867-769C-4579-85AA-BC684819BCF3}"/>
+                <a16:creationId xmlns:a16="http://schemas.microsoft.com/office/drawing/2014/main" id="{DFCC9258-A40A-451A-A78F-829EB9BC4665}"/>
               </a:ext>
             </a:extLst>
           </p:cNvPr>
@@ -2731,7 +2731,7 @@
           <p:cNvPr id="51" name="header-cape-gradient-18">
             <a:extLst xmlns:a="http://schemas.openxmlformats.org/drawingml/2006/main">
               <a:ext uri="{FF2B5EF4-FFF2-40B4-BE49-F238E27FC236}">
-                <a16:creationId xmlns:a16="http://schemas.microsoft.com/office/drawing/2014/main" id="{55B77965-32FC-44F3-8E92-B63FB9C2D93D}"/>
+                <a16:creationId xmlns:a16="http://schemas.microsoft.com/office/drawing/2014/main" id="{31C247D2-3620-434C-B96C-B32A780DF494}"/>
               </a:ext>
             </a:extLst>
           </p:cNvPr>
@@ -2764,7 +2764,7 @@
           <p:cNvPr id="52" name="header-cape-gradient-19">
             <a:extLst xmlns:a="http://schemas.openxmlformats.org/drawingml/2006/main">
               <a:ext uri="{FF2B5EF4-FFF2-40B4-BE49-F238E27FC236}">
-                <a16:creationId xmlns:a16="http://schemas.microsoft.com/office/drawing/2014/main" id="{F496C8EA-DF6F-4BE4-82C3-F80F3A385700}"/>
+                <a16:creationId xmlns:a16="http://schemas.microsoft.com/office/drawing/2014/main" id="{2AD6DA35-B204-4EAE-972F-5D36E5C9D410}"/>
               </a:ext>
             </a:extLst>
           </p:cNvPr>
@@ -2797,7 +2797,7 @@
           <p:cNvPr id="53" name="header-cape-gradient-20">
             <a:extLst xmlns:a="http://schemas.openxmlformats.org/drawingml/2006/main">
               <a:ext uri="{FF2B5EF4-FFF2-40B4-BE49-F238E27FC236}">
-                <a16:creationId xmlns:a16="http://schemas.microsoft.com/office/drawing/2014/main" id="{9B2C24B9-3E4B-4E2E-98D7-07278219F001}"/>
+                <a16:creationId xmlns:a16="http://schemas.microsoft.com/office/drawing/2014/main" id="{5A7BF34C-E042-42D9-A9CA-DD82F6A0D136}"/>
               </a:ext>
             </a:extLst>
           </p:cNvPr>
@@ -2830,7 +2830,7 @@
           <p:cNvPr id="54" name="header-cape-gradient-21">
             <a:extLst xmlns:a="http://schemas.openxmlformats.org/drawingml/2006/main">
               <a:ext uri="{FF2B5EF4-FFF2-40B4-BE49-F238E27FC236}">
-                <a16:creationId xmlns:a16="http://schemas.microsoft.com/office/drawing/2014/main" id="{8373C4D0-ED91-42B7-9CE1-65F1453D6167}"/>
+                <a16:creationId xmlns:a16="http://schemas.microsoft.com/office/drawing/2014/main" id="{B3B75033-9B8F-4278-AF79-8E70B8374878}"/>
               </a:ext>
             </a:extLst>
           </p:cNvPr>
@@ -2863,7 +2863,7 @@
           <p:cNvPr id="55" name="header-cape-gradient-22">
             <a:extLst xmlns:a="http://schemas.openxmlformats.org/drawingml/2006/main">
               <a:ext uri="{FF2B5EF4-FFF2-40B4-BE49-F238E27FC236}">
-                <a16:creationId xmlns:a16="http://schemas.microsoft.com/office/drawing/2014/main" id="{C4FE851F-BB6B-4CB9-B7C5-EF45B7EE3A22}"/>
+                <a16:creationId xmlns:a16="http://schemas.microsoft.com/office/drawing/2014/main" id="{EF14F13D-22BC-41A9-9805-C2FAE64C033C}"/>
               </a:ext>
             </a:extLst>
           </p:cNvPr>
@@ -2896,7 +2896,7 @@
           <p:cNvPr id="56" name="header-cape-gradient-23">
             <a:extLst xmlns:a="http://schemas.openxmlformats.org/drawingml/2006/main">
               <a:ext uri="{FF2B5EF4-FFF2-40B4-BE49-F238E27FC236}">
-                <a16:creationId xmlns:a16="http://schemas.microsoft.com/office/drawing/2014/main" id="{260B657D-D6DB-456F-8CB4-B57BD7965B78}"/>
+                <a16:creationId xmlns:a16="http://schemas.microsoft.com/office/drawing/2014/main" id="{785C10EC-165A-4DA6-B4FF-760774674FCC}"/>
               </a:ext>
             </a:extLst>
           </p:cNvPr>
@@ -2929,7 +2929,7 @@
           <p:cNvPr id="57" name="header-cape-gradient-24">
             <a:extLst xmlns:a="http://schemas.openxmlformats.org/drawingml/2006/main">
               <a:ext uri="{FF2B5EF4-FFF2-40B4-BE49-F238E27FC236}">
-                <a16:creationId xmlns:a16="http://schemas.microsoft.com/office/drawing/2014/main" id="{D524FD5C-3769-432B-924E-D1065F6CFAB8}"/>
+                <a16:creationId xmlns:a16="http://schemas.microsoft.com/office/drawing/2014/main" id="{98C69371-6B09-465A-9A7B-F88C3DFD4695}"/>
               </a:ext>
             </a:extLst>
           </p:cNvPr>
@@ -2962,7 +2962,7 @@
           <p:cNvPr id="58" name="header-cape-gradient-25">
             <a:extLst xmlns:a="http://schemas.openxmlformats.org/drawingml/2006/main">
               <a:ext uri="{FF2B5EF4-FFF2-40B4-BE49-F238E27FC236}">
-                <a16:creationId xmlns:a16="http://schemas.microsoft.com/office/drawing/2014/main" id="{6A3AE94A-6A3D-4D51-9EF8-DEE8D6E91DF4}"/>
+                <a16:creationId xmlns:a16="http://schemas.microsoft.com/office/drawing/2014/main" id="{74F4CD2E-E4D4-4C3A-A25F-509AB6E45724}"/>
               </a:ext>
             </a:extLst>
           </p:cNvPr>
@@ -2995,7 +2995,7 @@
           <p:cNvPr id="59" name="header-cape-gradient-26">
             <a:extLst xmlns:a="http://schemas.openxmlformats.org/drawingml/2006/main">
               <a:ext uri="{FF2B5EF4-FFF2-40B4-BE49-F238E27FC236}">
-                <a16:creationId xmlns:a16="http://schemas.microsoft.com/office/drawing/2014/main" id="{C281C931-F2CD-4701-9DA0-4FE6573F8B6E}"/>
+                <a16:creationId xmlns:a16="http://schemas.microsoft.com/office/drawing/2014/main" id="{917A7BAB-42CA-4837-A20D-FE0DC58A8A0B}"/>
               </a:ext>
             </a:extLst>
           </p:cNvPr>
@@ -3028,7 +3028,7 @@
           <p:cNvPr id="60" name="header-cape-gradient-27">
             <a:extLst xmlns:a="http://schemas.openxmlformats.org/drawingml/2006/main">
               <a:ext uri="{FF2B5EF4-FFF2-40B4-BE49-F238E27FC236}">
-                <a16:creationId xmlns:a16="http://schemas.microsoft.com/office/drawing/2014/main" id="{51641786-81E0-4BDB-9442-584107B485C3}"/>
+                <a16:creationId xmlns:a16="http://schemas.microsoft.com/office/drawing/2014/main" id="{DC35B9D5-5092-4934-B511-A9504E06FE8C}"/>
               </a:ext>
             </a:extLst>
           </p:cNvPr>
@@ -3061,7 +3061,7 @@
           <p:cNvPr id="61" name="header-cape-gradient-28">
             <a:extLst xmlns:a="http://schemas.openxmlformats.org/drawingml/2006/main">
               <a:ext uri="{FF2B5EF4-FFF2-40B4-BE49-F238E27FC236}">
-                <a16:creationId xmlns:a16="http://schemas.microsoft.com/office/drawing/2014/main" id="{5FB986AD-7E8B-40E7-80C3-B1702DBC0786}"/>
+                <a16:creationId xmlns:a16="http://schemas.microsoft.com/office/drawing/2014/main" id="{91AA4D36-177A-4E54-A4B8-86819294CC40}"/>
               </a:ext>
             </a:extLst>
           </p:cNvPr>
@@ -3094,7 +3094,7 @@
           <p:cNvPr id="62" name="header-cape-gradient-29">
             <a:extLst xmlns:a="http://schemas.openxmlformats.org/drawingml/2006/main">
               <a:ext uri="{FF2B5EF4-FFF2-40B4-BE49-F238E27FC236}">
-                <a16:creationId xmlns:a16="http://schemas.microsoft.com/office/drawing/2014/main" id="{7113BFD6-B8A8-4A8F-AD1A-FCB8F37B2660}"/>
+                <a16:creationId xmlns:a16="http://schemas.microsoft.com/office/drawing/2014/main" id="{B2A71CED-D6B0-40C6-B75F-78D1806397D9}"/>
               </a:ext>
             </a:extLst>
           </p:cNvPr>
@@ -3127,7 +3127,7 @@
           <p:cNvPr id="63" name="header-cape-gradient-30">
             <a:extLst xmlns:a="http://schemas.openxmlformats.org/drawingml/2006/main">
               <a:ext uri="{FF2B5EF4-FFF2-40B4-BE49-F238E27FC236}">
-                <a16:creationId xmlns:a16="http://schemas.microsoft.com/office/drawing/2014/main" id="{C1FABAE5-DA05-4860-947C-A81EAA52E74C}"/>
+                <a16:creationId xmlns:a16="http://schemas.microsoft.com/office/drawing/2014/main" id="{472965D2-DBB0-4E9F-ADB9-585F8E073F41}"/>
               </a:ext>
             </a:extLst>
           </p:cNvPr>
@@ -3160,7 +3160,7 @@
           <p:cNvPr id="64" name="header-cape-gradient-31">
             <a:extLst xmlns:a="http://schemas.openxmlformats.org/drawingml/2006/main">
               <a:ext uri="{FF2B5EF4-FFF2-40B4-BE49-F238E27FC236}">
-                <a16:creationId xmlns:a16="http://schemas.microsoft.com/office/drawing/2014/main" id="{DB62E06A-8673-430F-A6EA-E303A527FD73}"/>
+                <a16:creationId xmlns:a16="http://schemas.microsoft.com/office/drawing/2014/main" id="{02A384B4-7E49-436D-A24A-B9545AE9B1B3}"/>
               </a:ext>
             </a:extLst>
           </p:cNvPr>
@@ -3193,7 +3193,7 @@
           <p:cNvPr id="65" name="header-cape-gradient-32">
             <a:extLst xmlns:a="http://schemas.openxmlformats.org/drawingml/2006/main">
               <a:ext uri="{FF2B5EF4-FFF2-40B4-BE49-F238E27FC236}">
-                <a16:creationId xmlns:a16="http://schemas.microsoft.com/office/drawing/2014/main" id="{6955EAA5-C7A9-4667-A3CA-9DBDF963204A}"/>
+                <a16:creationId xmlns:a16="http://schemas.microsoft.com/office/drawing/2014/main" id="{DD6E3810-0726-4C47-8F6F-2F4774001532}"/>
               </a:ext>
             </a:extLst>
           </p:cNvPr>
@@ -3226,7 +3226,7 @@
           <p:cNvPr id="66" name="poster-title">
             <a:extLst xmlns:a="http://schemas.openxmlformats.org/drawingml/2006/main">
               <a:ext uri="{FF2B5EF4-FFF2-40B4-BE49-F238E27FC236}">
-                <a16:creationId xmlns:a16="http://schemas.microsoft.com/office/drawing/2014/main" id="{6634F986-30EA-4401-809E-2B055849D414}"/>
+                <a16:creationId xmlns:a16="http://schemas.microsoft.com/office/drawing/2014/main" id="{25CB523D-C019-4B67-A5B5-93DDB8D3DEEC}"/>
               </a:ext>
             </a:extLst>
           </p:cNvPr>
@@ -3293,7 +3293,7 @@
           <p:cNvPr id="67" name="authors">
             <a:extLst xmlns:a="http://schemas.openxmlformats.org/drawingml/2006/main">
               <a:ext uri="{FF2B5EF4-FFF2-40B4-BE49-F238E27FC236}">
-                <a16:creationId xmlns:a16="http://schemas.microsoft.com/office/drawing/2014/main" id="{D4B2BCA4-965C-43C0-B8B7-6F4DA2857ECB}"/>
+                <a16:creationId xmlns:a16="http://schemas.microsoft.com/office/drawing/2014/main" id="{26B4D3DB-E0B2-4502-9F61-8EC7F47D6B46}"/>
               </a:ext>
             </a:extLst>
           </p:cNvPr>
@@ -3343,7 +3343,7 @@
           <p:cNvPr id="68" name="affiliations">
             <a:extLst xmlns:a="http://schemas.openxmlformats.org/drawingml/2006/main">
               <a:ext uri="{FF2B5EF4-FFF2-40B4-BE49-F238E27FC236}">
-                <a16:creationId xmlns:a16="http://schemas.microsoft.com/office/drawing/2014/main" id="{37D78F8E-93E0-4A03-BF11-8B9C89FDB87E}"/>
+                <a16:creationId xmlns:a16="http://schemas.microsoft.com/office/drawing/2014/main" id="{41AB7AE2-1FFA-4185-8607-9BD71FD6D49E}"/>
               </a:ext>
             </a:extLst>
           </p:cNvPr>
@@ -3393,7 +3393,7 @@
           <p:cNvPr id="69" name="citation">
             <a:extLst xmlns:a="http://schemas.openxmlformats.org/drawingml/2006/main">
               <a:ext uri="{FF2B5EF4-FFF2-40B4-BE49-F238E27FC236}">
-                <a16:creationId xmlns:a16="http://schemas.microsoft.com/office/drawing/2014/main" id="{B4D7E468-A4AF-4B3B-8718-A939471A29FE}"/>
+                <a16:creationId xmlns:a16="http://schemas.microsoft.com/office/drawing/2014/main" id="{39EC7AD0-90C2-4304-9BE9-63D5F0D6B2C1}"/>
               </a:ext>
             </a:extLst>
           </p:cNvPr>
@@ -3443,7 +3443,7 @@
           <p:cNvPr id="70" name="logo-slot-fictional-lab-logo">
             <a:extLst xmlns:a="http://schemas.openxmlformats.org/drawingml/2006/main">
               <a:ext uri="{FF2B5EF4-FFF2-40B4-BE49-F238E27FC236}">
-                <a16:creationId xmlns:a16="http://schemas.microsoft.com/office/drawing/2014/main" id="{A5AC57DE-3791-4077-A0BA-A91B8314AA69}"/>
+                <a16:creationId xmlns:a16="http://schemas.microsoft.com/office/drawing/2014/main" id="{EA469AA8-B504-4531-8320-772A49C112A1}"/>
               </a:ext>
             </a:extLst>
           </p:cNvPr>
@@ -3478,7 +3478,7 @@
           <p:cNvPr id="71" name="logo-placeholder-fictional-lab-logo">
             <a:extLst xmlns:a="http://schemas.openxmlformats.org/drawingml/2006/main">
               <a:ext uri="{FF2B5EF4-FFF2-40B4-BE49-F238E27FC236}">
-                <a16:creationId xmlns:a16="http://schemas.microsoft.com/office/drawing/2014/main" id="{DDA64AD0-9529-4733-9764-B6153364A078}"/>
+                <a16:creationId xmlns:a16="http://schemas.microsoft.com/office/drawing/2014/main" id="{709628CC-2941-4CDA-9482-3435F002FA97}"/>
               </a:ext>
             </a:extLst>
           </p:cNvPr>
@@ -3528,7 +3528,7 @@
           <p:cNvPr id="72" name="header-summary">
             <a:extLst xmlns:a="http://schemas.openxmlformats.org/drawingml/2006/main">
               <a:ext uri="{FF2B5EF4-FFF2-40B4-BE49-F238E27FC236}">
-                <a16:creationId xmlns:a16="http://schemas.microsoft.com/office/drawing/2014/main" id="{E557AD6C-9809-4BCB-AB72-42F7D8C94865}"/>
+                <a16:creationId xmlns:a16="http://schemas.microsoft.com/office/drawing/2014/main" id="{DDFB5DCB-39BE-40F5-AF24-8C8F21E1989E}"/>
               </a:ext>
             </a:extLst>
           </p:cNvPr>
@@ -3561,7 +3561,7 @@
           <p:cNvPr id="73" name="header-metric-1-value">
             <a:extLst xmlns:a="http://schemas.openxmlformats.org/drawingml/2006/main">
               <a:ext uri="{FF2B5EF4-FFF2-40B4-BE49-F238E27FC236}">
-                <a16:creationId xmlns:a16="http://schemas.microsoft.com/office/drawing/2014/main" id="{7418A818-B677-4423-B64F-DBCAB0B7BBDB}"/>
+                <a16:creationId xmlns:a16="http://schemas.microsoft.com/office/drawing/2014/main" id="{1E28AAB6-9CF9-4509-8031-0E67A9A0491B}"/>
               </a:ext>
             </a:extLst>
           </p:cNvPr>
@@ -3611,7 +3611,7 @@
           <p:cNvPr id="74" name="header-metric-1-label">
             <a:extLst xmlns:a="http://schemas.openxmlformats.org/drawingml/2006/main">
               <a:ext uri="{FF2B5EF4-FFF2-40B4-BE49-F238E27FC236}">
-                <a16:creationId xmlns:a16="http://schemas.microsoft.com/office/drawing/2014/main" id="{A0EADB9C-F8EA-4F68-8DA0-C46FE533C1D1}"/>
+                <a16:creationId xmlns:a16="http://schemas.microsoft.com/office/drawing/2014/main" id="{978A464E-747F-479D-8729-94C1A514D25C}"/>
               </a:ext>
             </a:extLst>
           </p:cNvPr>
@@ -3661,7 +3661,7 @@
           <p:cNvPr id="75" name="header-metric-2-value">
             <a:extLst xmlns:a="http://schemas.openxmlformats.org/drawingml/2006/main">
               <a:ext uri="{FF2B5EF4-FFF2-40B4-BE49-F238E27FC236}">
-                <a16:creationId xmlns:a16="http://schemas.microsoft.com/office/drawing/2014/main" id="{E17AFC8B-F258-43DA-ABA7-2E770FA25A5E}"/>
+                <a16:creationId xmlns:a16="http://schemas.microsoft.com/office/drawing/2014/main" id="{020AA766-851B-443E-9DEF-AC2665F5FEA8}"/>
               </a:ext>
             </a:extLst>
           </p:cNvPr>
@@ -3711,7 +3711,7 @@
           <p:cNvPr id="76" name="header-metric-2-label">
             <a:extLst xmlns:a="http://schemas.openxmlformats.org/drawingml/2006/main">
               <a:ext uri="{FF2B5EF4-FFF2-40B4-BE49-F238E27FC236}">
-                <a16:creationId xmlns:a16="http://schemas.microsoft.com/office/drawing/2014/main" id="{CFF52072-809A-474D-A6A3-E604BE228AC4}"/>
+                <a16:creationId xmlns:a16="http://schemas.microsoft.com/office/drawing/2014/main" id="{787F4FA0-CF65-4885-8883-664A139F1FD3}"/>
               </a:ext>
             </a:extLst>
           </p:cNvPr>
@@ -3761,7 +3761,7 @@
           <p:cNvPr id="77" name="header-metric-3-value">
             <a:extLst xmlns:a="http://schemas.openxmlformats.org/drawingml/2006/main">
               <a:ext uri="{FF2B5EF4-FFF2-40B4-BE49-F238E27FC236}">
-                <a16:creationId xmlns:a16="http://schemas.microsoft.com/office/drawing/2014/main" id="{019472EF-ED39-4FEB-A183-024B807A36AD}"/>
+                <a16:creationId xmlns:a16="http://schemas.microsoft.com/office/drawing/2014/main" id="{07980263-1D7B-4E08-8963-3EED1F347313}"/>
               </a:ext>
             </a:extLst>
           </p:cNvPr>
@@ -3811,7 +3811,7 @@
           <p:cNvPr id="78" name="header-metric-3-label">
             <a:extLst xmlns:a="http://schemas.openxmlformats.org/drawingml/2006/main">
               <a:ext uri="{FF2B5EF4-FFF2-40B4-BE49-F238E27FC236}">
-                <a16:creationId xmlns:a16="http://schemas.microsoft.com/office/drawing/2014/main" id="{9EB01270-6289-4824-8857-5AF5FD3C5C99}"/>
+                <a16:creationId xmlns:a16="http://schemas.microsoft.com/office/drawing/2014/main" id="{1E1C8C27-6FA5-4FEB-A5E1-2D6A5FA74D4F}"/>
               </a:ext>
             </a:extLst>
           </p:cNvPr>
@@ -3861,7 +3861,7 @@
           <p:cNvPr id="79" name="question-title">
             <a:extLst xmlns:a="http://schemas.openxmlformats.org/drawingml/2006/main">
               <a:ext uri="{FF2B5EF4-FFF2-40B4-BE49-F238E27FC236}">
-                <a16:creationId xmlns:a16="http://schemas.microsoft.com/office/drawing/2014/main" id="{E2D76CBB-815C-446F-A859-6B804AAB96DC}"/>
+                <a16:creationId xmlns:a16="http://schemas.microsoft.com/office/drawing/2014/main" id="{4CB49220-9EC9-48ED-BD3C-A52415303DD6}"/>
               </a:ext>
             </a:extLst>
           </p:cNvPr>
@@ -3911,7 +3911,7 @@
           <p:cNvPr id="80" name="question-rule">
             <a:extLst xmlns:a="http://schemas.openxmlformats.org/drawingml/2006/main">
               <a:ext uri="{FF2B5EF4-FFF2-40B4-BE49-F238E27FC236}">
-                <a16:creationId xmlns:a16="http://schemas.microsoft.com/office/drawing/2014/main" id="{23CDFFCE-22F6-4F70-A10A-73171054A607}"/>
+                <a16:creationId xmlns:a16="http://schemas.microsoft.com/office/drawing/2014/main" id="{F4306CFF-C66E-4C17-8ECB-3CDE706C39EC}"/>
               </a:ext>
             </a:extLst>
           </p:cNvPr>
@@ -3944,7 +3944,7 @@
           <p:cNvPr id="81" name="research-question">
             <a:extLst xmlns:a="http://schemas.openxmlformats.org/drawingml/2006/main">
               <a:ext uri="{FF2B5EF4-FFF2-40B4-BE49-F238E27FC236}">
-                <a16:creationId xmlns:a16="http://schemas.microsoft.com/office/drawing/2014/main" id="{18A38E25-AB60-409B-8C0D-804A10D789DC}"/>
+                <a16:creationId xmlns:a16="http://schemas.microsoft.com/office/drawing/2014/main" id="{EEBEEFA2-E9D3-4165-BC35-643925AE7238}"/>
               </a:ext>
             </a:extLst>
           </p:cNvPr>
@@ -3994,7 +3994,7 @@
           <p:cNvPr id="82" name="question-evidence">
             <a:extLst xmlns:a="http://schemas.openxmlformats.org/drawingml/2006/main">
               <a:ext uri="{FF2B5EF4-FFF2-40B4-BE49-F238E27FC236}">
-                <a16:creationId xmlns:a16="http://schemas.microsoft.com/office/drawing/2014/main" id="{5F1DC97D-A60D-43E2-B2AB-DA08BFBE4B54}"/>
+                <a16:creationId xmlns:a16="http://schemas.microsoft.com/office/drawing/2014/main" id="{F164FDD3-B37E-4BAE-835E-D308AF6DBC81}"/>
               </a:ext>
             </a:extLst>
           </p:cNvPr>
@@ -4044,7 +4044,7 @@
           <p:cNvPr id="83" name="pipeline-title">
             <a:extLst xmlns:a="http://schemas.openxmlformats.org/drawingml/2006/main">
               <a:ext uri="{FF2B5EF4-FFF2-40B4-BE49-F238E27FC236}">
-                <a16:creationId xmlns:a16="http://schemas.microsoft.com/office/drawing/2014/main" id="{7CA700DD-A012-4AD2-9874-D6AA4BA0B29E}"/>
+                <a16:creationId xmlns:a16="http://schemas.microsoft.com/office/drawing/2014/main" id="{A3C63E06-F535-4F8B-AC55-FB3942067C6F}"/>
               </a:ext>
             </a:extLst>
           </p:cNvPr>
@@ -4094,7 +4094,7 @@
           <p:cNvPr id="84" name="pipeline-rule">
             <a:extLst xmlns:a="http://schemas.openxmlformats.org/drawingml/2006/main">
               <a:ext uri="{FF2B5EF4-FFF2-40B4-BE49-F238E27FC236}">
-                <a16:creationId xmlns:a16="http://schemas.microsoft.com/office/drawing/2014/main" id="{E51A7079-E0A0-4319-A9EE-F7EBF8B59E47}"/>
+                <a16:creationId xmlns:a16="http://schemas.microsoft.com/office/drawing/2014/main" id="{1EEA1A8E-0926-4EA8-ABEC-A57888DBB06D}"/>
               </a:ext>
             </a:extLst>
           </p:cNvPr>
@@ -4127,7 +4127,7 @@
           <p:cNvPr id="85" name="pipeline-1-number-bg">
             <a:extLst xmlns:a="http://schemas.openxmlformats.org/drawingml/2006/main">
               <a:ext uri="{FF2B5EF4-FFF2-40B4-BE49-F238E27FC236}">
-                <a16:creationId xmlns:a16="http://schemas.microsoft.com/office/drawing/2014/main" id="{CB865C69-9BDE-4FC3-8364-808BCB6C6E68}"/>
+                <a16:creationId xmlns:a16="http://schemas.microsoft.com/office/drawing/2014/main" id="{D01033A2-AB7C-494A-AD6C-73B229CAC0F3}"/>
               </a:ext>
             </a:extLst>
           </p:cNvPr>
@@ -4160,7 +4160,7 @@
           <p:cNvPr id="86" name="pipeline-1-number">
             <a:extLst xmlns:a="http://schemas.openxmlformats.org/drawingml/2006/main">
               <a:ext uri="{FF2B5EF4-FFF2-40B4-BE49-F238E27FC236}">
-                <a16:creationId xmlns:a16="http://schemas.microsoft.com/office/drawing/2014/main" id="{2B81A4DA-865D-435D-94E0-627530488455}"/>
+                <a16:creationId xmlns:a16="http://schemas.microsoft.com/office/drawing/2014/main" id="{91D8655E-98FC-4222-B3B8-D8B537290008}"/>
               </a:ext>
             </a:extLst>
           </p:cNvPr>
@@ -4210,7 +4210,7 @@
           <p:cNvPr id="87" name="pipeline-1-text">
             <a:extLst xmlns:a="http://schemas.openxmlformats.org/drawingml/2006/main">
               <a:ext uri="{FF2B5EF4-FFF2-40B4-BE49-F238E27FC236}">
-                <a16:creationId xmlns:a16="http://schemas.microsoft.com/office/drawing/2014/main" id="{271F36CF-529E-40A4-8D7D-CC8E898C74C6}"/>
+                <a16:creationId xmlns:a16="http://schemas.microsoft.com/office/drawing/2014/main" id="{4652BA32-5728-4074-8E02-E7C29D7B1499}"/>
               </a:ext>
             </a:extLst>
           </p:cNvPr>
@@ -4260,7 +4260,7 @@
           <p:cNvPr id="88" name="pipeline-2-number-bg">
             <a:extLst xmlns:a="http://schemas.openxmlformats.org/drawingml/2006/main">
               <a:ext uri="{FF2B5EF4-FFF2-40B4-BE49-F238E27FC236}">
-                <a16:creationId xmlns:a16="http://schemas.microsoft.com/office/drawing/2014/main" id="{3091B8C6-C983-4AA6-A25C-DFD10A4FE0BF}"/>
+                <a16:creationId xmlns:a16="http://schemas.microsoft.com/office/drawing/2014/main" id="{27FEF669-E6DA-43D6-92BE-53D375E22889}"/>
               </a:ext>
             </a:extLst>
           </p:cNvPr>
@@ -4293,7 +4293,7 @@
           <p:cNvPr id="89" name="pipeline-2-number">
             <a:extLst xmlns:a="http://schemas.openxmlformats.org/drawingml/2006/main">
               <a:ext uri="{FF2B5EF4-FFF2-40B4-BE49-F238E27FC236}">
-                <a16:creationId xmlns:a16="http://schemas.microsoft.com/office/drawing/2014/main" id="{4C60B59C-E0D1-44FC-91A0-1FB38F260A96}"/>
+                <a16:creationId xmlns:a16="http://schemas.microsoft.com/office/drawing/2014/main" id="{783E5E9C-0848-4DDA-9862-826A14BD9525}"/>
               </a:ext>
             </a:extLst>
           </p:cNvPr>
@@ -4343,7 +4343,7 @@
           <p:cNvPr id="90" name="pipeline-2-text">
             <a:extLst xmlns:a="http://schemas.openxmlformats.org/drawingml/2006/main">
               <a:ext uri="{FF2B5EF4-FFF2-40B4-BE49-F238E27FC236}">
-                <a16:creationId xmlns:a16="http://schemas.microsoft.com/office/drawing/2014/main" id="{3B4FC8AF-A76F-48C1-83E1-8495B79C2308}"/>
+                <a16:creationId xmlns:a16="http://schemas.microsoft.com/office/drawing/2014/main" id="{6AC72E0A-FB60-4ACA-81D2-5E83CC1322F8}"/>
               </a:ext>
             </a:extLst>
           </p:cNvPr>
@@ -4393,7 +4393,7 @@
           <p:cNvPr id="91" name="pipeline-3-number-bg">
             <a:extLst xmlns:a="http://schemas.openxmlformats.org/drawingml/2006/main">
               <a:ext uri="{FF2B5EF4-FFF2-40B4-BE49-F238E27FC236}">
-                <a16:creationId xmlns:a16="http://schemas.microsoft.com/office/drawing/2014/main" id="{55951045-9349-457A-B7AC-CB6B2C278ECC}"/>
+                <a16:creationId xmlns:a16="http://schemas.microsoft.com/office/drawing/2014/main" id="{22E78DE1-0D03-4A05-8AFE-9D6B90E4DD48}"/>
               </a:ext>
             </a:extLst>
           </p:cNvPr>
@@ -4426,7 +4426,7 @@
           <p:cNvPr id="92" name="pipeline-3-number">
             <a:extLst xmlns:a="http://schemas.openxmlformats.org/drawingml/2006/main">
               <a:ext uri="{FF2B5EF4-FFF2-40B4-BE49-F238E27FC236}">
-                <a16:creationId xmlns:a16="http://schemas.microsoft.com/office/drawing/2014/main" id="{2572C78E-DFC0-4B6C-8815-BC84EBF8E555}"/>
+                <a16:creationId xmlns:a16="http://schemas.microsoft.com/office/drawing/2014/main" id="{184827B9-230C-4E6A-8158-1EA2924CC7CE}"/>
               </a:ext>
             </a:extLst>
           </p:cNvPr>
@@ -4476,7 +4476,7 @@
           <p:cNvPr id="93" name="pipeline-3-text">
             <a:extLst xmlns:a="http://schemas.openxmlformats.org/drawingml/2006/main">
               <a:ext uri="{FF2B5EF4-FFF2-40B4-BE49-F238E27FC236}">
-                <a16:creationId xmlns:a16="http://schemas.microsoft.com/office/drawing/2014/main" id="{A12DF549-F596-447E-96B3-2551759B0A01}"/>
+                <a16:creationId xmlns:a16="http://schemas.microsoft.com/office/drawing/2014/main" id="{F84836ED-2415-47E4-BC43-2D56593630B8}"/>
               </a:ext>
             </a:extLst>
           </p:cNvPr>
@@ -4526,7 +4526,7 @@
           <p:cNvPr id="94" name="pipeline-4-number-bg">
             <a:extLst xmlns:a="http://schemas.openxmlformats.org/drawingml/2006/main">
               <a:ext uri="{FF2B5EF4-FFF2-40B4-BE49-F238E27FC236}">
-                <a16:creationId xmlns:a16="http://schemas.microsoft.com/office/drawing/2014/main" id="{40C331DC-3F4C-45D3-8F02-0F3DA1CF222B}"/>
+                <a16:creationId xmlns:a16="http://schemas.microsoft.com/office/drawing/2014/main" id="{7250E9AD-78EE-487C-87D7-D9CA0C2028C0}"/>
               </a:ext>
             </a:extLst>
           </p:cNvPr>
@@ -4559,7 +4559,7 @@
           <p:cNvPr id="95" name="pipeline-4-number">
             <a:extLst xmlns:a="http://schemas.openxmlformats.org/drawingml/2006/main">
               <a:ext uri="{FF2B5EF4-FFF2-40B4-BE49-F238E27FC236}">
-                <a16:creationId xmlns:a16="http://schemas.microsoft.com/office/drawing/2014/main" id="{1694FE84-6944-46E1-95D4-06BA713337E6}"/>
+                <a16:creationId xmlns:a16="http://schemas.microsoft.com/office/drawing/2014/main" id="{22069F4A-51F4-4E47-9083-E399A51C875E}"/>
               </a:ext>
             </a:extLst>
           </p:cNvPr>
@@ -4609,7 +4609,7 @@
           <p:cNvPr id="96" name="pipeline-4-text">
             <a:extLst xmlns:a="http://schemas.openxmlformats.org/drawingml/2006/main">
               <a:ext uri="{FF2B5EF4-FFF2-40B4-BE49-F238E27FC236}">
-                <a16:creationId xmlns:a16="http://schemas.microsoft.com/office/drawing/2014/main" id="{32730EB6-DD76-4CFC-BE9F-884846F48BBF}"/>
+                <a16:creationId xmlns:a16="http://schemas.microsoft.com/office/drawing/2014/main" id="{64DB6B19-255C-42C3-9334-565ED180C7EC}"/>
               </a:ext>
             </a:extLst>
           </p:cNvPr>
@@ -4659,7 +4659,7 @@
           <p:cNvPr id="97" name="dataset-panel">
             <a:extLst xmlns:a="http://schemas.openxmlformats.org/drawingml/2006/main">
               <a:ext uri="{FF2B5EF4-FFF2-40B4-BE49-F238E27FC236}">
-                <a16:creationId xmlns:a16="http://schemas.microsoft.com/office/drawing/2014/main" id="{117CEA0C-CED6-4A73-950C-8D187FAC22EB}"/>
+                <a16:creationId xmlns:a16="http://schemas.microsoft.com/office/drawing/2014/main" id="{73F32347-F730-49B7-977D-96F78318E94B}"/>
               </a:ext>
             </a:extLst>
           </p:cNvPr>
@@ -4694,7 +4694,7 @@
           <p:cNvPr id="98" name="dataset-kicker">
             <a:extLst xmlns:a="http://schemas.openxmlformats.org/drawingml/2006/main">
               <a:ext uri="{FF2B5EF4-FFF2-40B4-BE49-F238E27FC236}">
-                <a16:creationId xmlns:a16="http://schemas.microsoft.com/office/drawing/2014/main" id="{C0A64742-EE3A-4D13-AD9E-A7C15BF8F655}"/>
+                <a16:creationId xmlns:a16="http://schemas.microsoft.com/office/drawing/2014/main" id="{FBA0AED9-FCCF-4696-8C5F-D397AD036143}"/>
               </a:ext>
             </a:extLst>
           </p:cNvPr>
@@ -4744,7 +4744,7 @@
           <p:cNvPr id="99" name="datasets">
             <a:extLst xmlns:a="http://schemas.openxmlformats.org/drawingml/2006/main">
               <a:ext uri="{FF2B5EF4-FFF2-40B4-BE49-F238E27FC236}">
-                <a16:creationId xmlns:a16="http://schemas.microsoft.com/office/drawing/2014/main" id="{C3161B6E-424C-41B0-BABD-3C64066265D5}"/>
+                <a16:creationId xmlns:a16="http://schemas.microsoft.com/office/drawing/2014/main" id="{675931BE-CBAC-46A9-9AF8-2986BAAE46D9}"/>
               </a:ext>
             </a:extLst>
           </p:cNvPr>
@@ -4828,7 +4828,7 @@
           <p:cNvPr id="100" name="dataset-evidence">
             <a:extLst xmlns:a="http://schemas.openxmlformats.org/drawingml/2006/main">
               <a:ext uri="{FF2B5EF4-FFF2-40B4-BE49-F238E27FC236}">
-                <a16:creationId xmlns:a16="http://schemas.microsoft.com/office/drawing/2014/main" id="{147C52E4-B9DB-4C58-865C-68080A9CC403}"/>
+                <a16:creationId xmlns:a16="http://schemas.microsoft.com/office/drawing/2014/main" id="{6116922F-55BC-4DB9-9A19-F2F9D47BE709}"/>
               </a:ext>
             </a:extLst>
           </p:cNvPr>
@@ -4878,7 +4878,7 @@
           <p:cNvPr id="101" name="figure-one-heading-title">
             <a:extLst xmlns:a="http://schemas.openxmlformats.org/drawingml/2006/main">
               <a:ext uri="{FF2B5EF4-FFF2-40B4-BE49-F238E27FC236}">
-                <a16:creationId xmlns:a16="http://schemas.microsoft.com/office/drawing/2014/main" id="{947587EB-84AD-46DA-9FAA-3DC6EF5F259E}"/>
+                <a16:creationId xmlns:a16="http://schemas.microsoft.com/office/drawing/2014/main" id="{B3D115C5-77FB-4377-AADB-598B6A732E0A}"/>
               </a:ext>
             </a:extLst>
           </p:cNvPr>
@@ -4928,7 +4928,7 @@
           <p:cNvPr id="102" name="figure-one-heading-rule">
             <a:extLst xmlns:a="http://schemas.openxmlformats.org/drawingml/2006/main">
               <a:ext uri="{FF2B5EF4-FFF2-40B4-BE49-F238E27FC236}">
-                <a16:creationId xmlns:a16="http://schemas.microsoft.com/office/drawing/2014/main" id="{2C4B7E28-223A-4FED-B6D5-F48B4B652E24}"/>
+                <a16:creationId xmlns:a16="http://schemas.microsoft.com/office/drawing/2014/main" id="{55E42B3B-E9B4-41E3-BA2F-CF1795B35DD1}"/>
               </a:ext>
             </a:extLst>
           </p:cNvPr>
@@ -4961,7 +4961,7 @@
           <p:cNvPr id="103" name="figure-one-frame">
             <a:extLst xmlns:a="http://schemas.openxmlformats.org/drawingml/2006/main">
               <a:ext uri="{FF2B5EF4-FFF2-40B4-BE49-F238E27FC236}">
-                <a16:creationId xmlns:a16="http://schemas.microsoft.com/office/drawing/2014/main" id="{12F38C90-22FF-4BA5-8D5A-F1F83E745DDC}"/>
+                <a16:creationId xmlns:a16="http://schemas.microsoft.com/office/drawing/2014/main" id="{7DCEC0B4-245C-4562-804B-E9F19B893970}"/>
               </a:ext>
             </a:extLst>
           </p:cNvPr>
@@ -5000,10 +5000,10 @@
           <p:nvPr/>
         </p:nvPicPr>
         <p:blipFill>
-          <a:blip xmlns:r="http://schemas.openxmlformats.org/officeDocument/2006/relationships" xmlns:a="http://schemas.openxmlformats.org/drawingml/2006/main" r:embed="R44f2575808024718">
+          <a:blip xmlns:r="http://schemas.openxmlformats.org/officeDocument/2006/relationships" xmlns:a="http://schemas.openxmlformats.org/drawingml/2006/main" r:embed="Rfb7a8ce4f7804485">
             <a:extLst>
               <a:ext uri="{96DAC541-7B7A-43D3-8B79-37D633B846F1}">
-                <asvg:svgBlip xmlns:asvg="http://schemas.microsoft.com/office/drawing/2016/SVG/main" r:embed="R7a8483fd58b94fe4"/>
+                <asvg:svgBlip xmlns:asvg="http://schemas.microsoft.com/office/drawing/2016/SVG/main" r:embed="Rdba4f05209d244fb"/>
               </a:ext>
             </a:extLst>
           </a:blip>
@@ -5024,7 +5024,7 @@
           <p:cNvPr id="105" name="figure-one-caption">
             <a:extLst xmlns:a="http://schemas.openxmlformats.org/drawingml/2006/main">
               <a:ext uri="{FF2B5EF4-FFF2-40B4-BE49-F238E27FC236}">
-                <a16:creationId xmlns:a16="http://schemas.microsoft.com/office/drawing/2014/main" id="{7F094A28-A18B-4DC1-B629-8EF71F08BF8A}"/>
+                <a16:creationId xmlns:a16="http://schemas.microsoft.com/office/drawing/2014/main" id="{60FB7584-0C9F-4752-B4B6-41DB97453358}"/>
               </a:ext>
             </a:extLst>
           </p:cNvPr>
@@ -5074,7 +5074,7 @@
           <p:cNvPr id="106" name="figure-one-source">
             <a:extLst xmlns:a="http://schemas.openxmlformats.org/drawingml/2006/main">
               <a:ext uri="{FF2B5EF4-FFF2-40B4-BE49-F238E27FC236}">
-                <a16:creationId xmlns:a16="http://schemas.microsoft.com/office/drawing/2014/main" id="{8E46A18D-AD11-4C14-850C-1FBD68957EE6}"/>
+                <a16:creationId xmlns:a16="http://schemas.microsoft.com/office/drawing/2014/main" id="{FE7CDF88-C1EF-479B-8A77-90F30ECE547A}"/>
               </a:ext>
             </a:extLst>
           </p:cNvPr>
@@ -5124,7 +5124,7 @@
           <p:cNvPr id="107" name="central-takeaway">
             <a:extLst xmlns:a="http://schemas.openxmlformats.org/drawingml/2006/main">
               <a:ext uri="{FF2B5EF4-FFF2-40B4-BE49-F238E27FC236}">
-                <a16:creationId xmlns:a16="http://schemas.microsoft.com/office/drawing/2014/main" id="{C26A5753-E4F6-4856-84A5-CE288D4645C8}"/>
+                <a16:creationId xmlns:a16="http://schemas.microsoft.com/office/drawing/2014/main" id="{9E2C29AB-3483-41B6-A6DD-9C36B71AAEB8}"/>
               </a:ext>
             </a:extLst>
           </p:cNvPr>
@@ -5157,7 +5157,7 @@
           <p:cNvPr id="108" name="takeaway-cape-gradient-1">
             <a:extLst xmlns:a="http://schemas.openxmlformats.org/drawingml/2006/main">
               <a:ext uri="{FF2B5EF4-FFF2-40B4-BE49-F238E27FC236}">
-                <a16:creationId xmlns:a16="http://schemas.microsoft.com/office/drawing/2014/main" id="{D29E0B1A-9498-4BA3-8A05-BE9D6BCC88EA}"/>
+                <a16:creationId xmlns:a16="http://schemas.microsoft.com/office/drawing/2014/main" id="{BA65FB15-E8F8-4FE8-8C8C-AF8B5273B616}"/>
               </a:ext>
             </a:extLst>
           </p:cNvPr>
@@ -5190,7 +5190,7 @@
           <p:cNvPr id="109" name="takeaway-cape-gradient-2">
             <a:extLst xmlns:a="http://schemas.openxmlformats.org/drawingml/2006/main">
               <a:ext uri="{FF2B5EF4-FFF2-40B4-BE49-F238E27FC236}">
-                <a16:creationId xmlns:a16="http://schemas.microsoft.com/office/drawing/2014/main" id="{26DCB2B3-E043-4763-9B38-B1B35DE4AF04}"/>
+                <a16:creationId xmlns:a16="http://schemas.microsoft.com/office/drawing/2014/main" id="{375C0D4C-BC88-45B5-BEED-117826A3CF34}"/>
               </a:ext>
             </a:extLst>
           </p:cNvPr>
@@ -5223,7 +5223,7 @@
           <p:cNvPr id="110" name="takeaway-cape-gradient-3">
             <a:extLst xmlns:a="http://schemas.openxmlformats.org/drawingml/2006/main">
               <a:ext uri="{FF2B5EF4-FFF2-40B4-BE49-F238E27FC236}">
-                <a16:creationId xmlns:a16="http://schemas.microsoft.com/office/drawing/2014/main" id="{39488243-A4CF-4788-8F31-24593058DBA9}"/>
+                <a16:creationId xmlns:a16="http://schemas.microsoft.com/office/drawing/2014/main" id="{E8564880-948C-4D5B-87BE-1B2F1A9B5D7B}"/>
               </a:ext>
             </a:extLst>
           </p:cNvPr>
@@ -5256,7 +5256,7 @@
           <p:cNvPr id="111" name="takeaway-cape-gradient-4">
             <a:extLst xmlns:a="http://schemas.openxmlformats.org/drawingml/2006/main">
               <a:ext uri="{FF2B5EF4-FFF2-40B4-BE49-F238E27FC236}">
-                <a16:creationId xmlns:a16="http://schemas.microsoft.com/office/drawing/2014/main" id="{10770232-E4C3-45E3-8BE4-8D38D3A133F2}"/>
+                <a16:creationId xmlns:a16="http://schemas.microsoft.com/office/drawing/2014/main" id="{3D0C3886-7F55-4248-905A-2ECDBA7CEB7A}"/>
               </a:ext>
             </a:extLst>
           </p:cNvPr>
@@ -5289,7 +5289,7 @@
           <p:cNvPr id="112" name="takeaway-cape-gradient-5">
             <a:extLst xmlns:a="http://schemas.openxmlformats.org/drawingml/2006/main">
               <a:ext uri="{FF2B5EF4-FFF2-40B4-BE49-F238E27FC236}">
-                <a16:creationId xmlns:a16="http://schemas.microsoft.com/office/drawing/2014/main" id="{1CD0CE72-1BDB-42D5-97D8-CD9A707931C1}"/>
+                <a16:creationId xmlns:a16="http://schemas.microsoft.com/office/drawing/2014/main" id="{FEF4B1B9-2370-4CF0-BD55-0951FCF0805D}"/>
               </a:ext>
             </a:extLst>
           </p:cNvPr>
@@ -5322,7 +5322,7 @@
           <p:cNvPr id="113" name="takeaway-cape-gradient-6">
             <a:extLst xmlns:a="http://schemas.openxmlformats.org/drawingml/2006/main">
               <a:ext uri="{FF2B5EF4-FFF2-40B4-BE49-F238E27FC236}">
-                <a16:creationId xmlns:a16="http://schemas.microsoft.com/office/drawing/2014/main" id="{E7492009-7750-4860-926F-67DC2984F6F8}"/>
+                <a16:creationId xmlns:a16="http://schemas.microsoft.com/office/drawing/2014/main" id="{6A72903F-CD2F-403C-8194-BF0B4C426596}"/>
               </a:ext>
             </a:extLst>
           </p:cNvPr>
@@ -5355,7 +5355,7 @@
           <p:cNvPr id="114" name="takeaway-cape-gradient-7">
             <a:extLst xmlns:a="http://schemas.openxmlformats.org/drawingml/2006/main">
               <a:ext uri="{FF2B5EF4-FFF2-40B4-BE49-F238E27FC236}">
-                <a16:creationId xmlns:a16="http://schemas.microsoft.com/office/drawing/2014/main" id="{11AB09E3-30D8-4DFB-8961-C80C2B35B725}"/>
+                <a16:creationId xmlns:a16="http://schemas.microsoft.com/office/drawing/2014/main" id="{47523580-6689-4920-8549-AE4F001A3648}"/>
               </a:ext>
             </a:extLst>
           </p:cNvPr>
@@ -5388,7 +5388,7 @@
           <p:cNvPr id="115" name="takeaway-cape-gradient-8">
             <a:extLst xmlns:a="http://schemas.openxmlformats.org/drawingml/2006/main">
               <a:ext uri="{FF2B5EF4-FFF2-40B4-BE49-F238E27FC236}">
-                <a16:creationId xmlns:a16="http://schemas.microsoft.com/office/drawing/2014/main" id="{90C5E2E7-0FA8-4D9D-90FF-7D192813AEF3}"/>
+                <a16:creationId xmlns:a16="http://schemas.microsoft.com/office/drawing/2014/main" id="{75656BCE-43B2-46E4-9FA7-A809309BFB3D}"/>
               </a:ext>
             </a:extLst>
           </p:cNvPr>
@@ -5421,7 +5421,7 @@
           <p:cNvPr id="116" name="takeaway-cape-gradient-9">
             <a:extLst xmlns:a="http://schemas.openxmlformats.org/drawingml/2006/main">
               <a:ext uri="{FF2B5EF4-FFF2-40B4-BE49-F238E27FC236}">
-                <a16:creationId xmlns:a16="http://schemas.microsoft.com/office/drawing/2014/main" id="{CAF9EDFE-1A04-4E9F-B15F-B0927D9BBC8F}"/>
+                <a16:creationId xmlns:a16="http://schemas.microsoft.com/office/drawing/2014/main" id="{1B83B228-C53B-40EE-B24E-643F935DA4FE}"/>
               </a:ext>
             </a:extLst>
           </p:cNvPr>
@@ -5454,7 +5454,7 @@
           <p:cNvPr id="117" name="takeaway-cape-gradient-10">
             <a:extLst xmlns:a="http://schemas.openxmlformats.org/drawingml/2006/main">
               <a:ext uri="{FF2B5EF4-FFF2-40B4-BE49-F238E27FC236}">
-                <a16:creationId xmlns:a16="http://schemas.microsoft.com/office/drawing/2014/main" id="{74EE29EA-A0F9-43F8-B507-9FD7C46101F3}"/>
+                <a16:creationId xmlns:a16="http://schemas.microsoft.com/office/drawing/2014/main" id="{67417977-F2EC-432E-B84E-383267F26F96}"/>
               </a:ext>
             </a:extLst>
           </p:cNvPr>
@@ -5487,7 +5487,7 @@
           <p:cNvPr id="118" name="takeaway-cape-gradient-11">
             <a:extLst xmlns:a="http://schemas.openxmlformats.org/drawingml/2006/main">
               <a:ext uri="{FF2B5EF4-FFF2-40B4-BE49-F238E27FC236}">
-                <a16:creationId xmlns:a16="http://schemas.microsoft.com/office/drawing/2014/main" id="{17436FE5-F304-4C9E-919F-D48A2F7E49C0}"/>
+                <a16:creationId xmlns:a16="http://schemas.microsoft.com/office/drawing/2014/main" id="{20E43B08-8722-4011-87FA-152A7390DF25}"/>
               </a:ext>
             </a:extLst>
           </p:cNvPr>
@@ -5520,7 +5520,7 @@
           <p:cNvPr id="119" name="takeaway-cape-gradient-12">
             <a:extLst xmlns:a="http://schemas.openxmlformats.org/drawingml/2006/main">
               <a:ext uri="{FF2B5EF4-FFF2-40B4-BE49-F238E27FC236}">
-                <a16:creationId xmlns:a16="http://schemas.microsoft.com/office/drawing/2014/main" id="{1A440098-4186-4C14-B633-5182A14DD1BE}"/>
+                <a16:creationId xmlns:a16="http://schemas.microsoft.com/office/drawing/2014/main" id="{7287C8EA-B05B-4699-B30C-FE3530EF6E25}"/>
               </a:ext>
             </a:extLst>
           </p:cNvPr>
@@ -5553,7 +5553,7 @@
           <p:cNvPr id="120" name="takeaway-cape-gradient-13">
             <a:extLst xmlns:a="http://schemas.openxmlformats.org/drawingml/2006/main">
               <a:ext uri="{FF2B5EF4-FFF2-40B4-BE49-F238E27FC236}">
-                <a16:creationId xmlns:a16="http://schemas.microsoft.com/office/drawing/2014/main" id="{E99B0A07-1F98-4F59-899E-7B88C39397D4}"/>
+                <a16:creationId xmlns:a16="http://schemas.microsoft.com/office/drawing/2014/main" id="{63F39E5C-7B5E-4470-9279-3FAFCBC81987}"/>
               </a:ext>
             </a:extLst>
           </p:cNvPr>
@@ -5586,7 +5586,7 @@
           <p:cNvPr id="121" name="takeaway-cape-gradient-14">
             <a:extLst xmlns:a="http://schemas.openxmlformats.org/drawingml/2006/main">
               <a:ext uri="{FF2B5EF4-FFF2-40B4-BE49-F238E27FC236}">
-                <a16:creationId xmlns:a16="http://schemas.microsoft.com/office/drawing/2014/main" id="{79F31869-1831-405A-884B-D979361D82EC}"/>
+                <a16:creationId xmlns:a16="http://schemas.microsoft.com/office/drawing/2014/main" id="{7B8CC637-9890-4DFD-BFDE-0EF589476FA0}"/>
               </a:ext>
             </a:extLst>
           </p:cNvPr>
@@ -5619,7 +5619,7 @@
           <p:cNvPr id="122" name="takeaway-cape-gradient-15">
             <a:extLst xmlns:a="http://schemas.openxmlformats.org/drawingml/2006/main">
               <a:ext uri="{FF2B5EF4-FFF2-40B4-BE49-F238E27FC236}">
-                <a16:creationId xmlns:a16="http://schemas.microsoft.com/office/drawing/2014/main" id="{EF4E09B5-F5DA-4AA9-BF03-B2BBEF727105}"/>
+                <a16:creationId xmlns:a16="http://schemas.microsoft.com/office/drawing/2014/main" id="{84026E13-0EE8-40FB-BDE9-E746324DD98A}"/>
               </a:ext>
             </a:extLst>
           </p:cNvPr>
@@ -5652,7 +5652,7 @@
           <p:cNvPr id="123" name="takeaway-cape-gradient-16">
             <a:extLst xmlns:a="http://schemas.openxmlformats.org/drawingml/2006/main">
               <a:ext uri="{FF2B5EF4-FFF2-40B4-BE49-F238E27FC236}">
-                <a16:creationId xmlns:a16="http://schemas.microsoft.com/office/drawing/2014/main" id="{CF7CA373-C205-4819-BDCF-B49739068E10}"/>
+                <a16:creationId xmlns:a16="http://schemas.microsoft.com/office/drawing/2014/main" id="{70432698-726F-4634-A100-4BB734C88AB9}"/>
               </a:ext>
             </a:extLst>
           </p:cNvPr>
@@ -5685,7 +5685,7 @@
           <p:cNvPr id="124" name="takeaway-cape-gradient-17">
             <a:extLst xmlns:a="http://schemas.openxmlformats.org/drawingml/2006/main">
               <a:ext uri="{FF2B5EF4-FFF2-40B4-BE49-F238E27FC236}">
-                <a16:creationId xmlns:a16="http://schemas.microsoft.com/office/drawing/2014/main" id="{C93151E8-4112-4F5F-A99D-6E45478D68CE}"/>
+                <a16:creationId xmlns:a16="http://schemas.microsoft.com/office/drawing/2014/main" id="{C8C3F27D-5F56-46AA-9305-6F2936FF68BB}"/>
               </a:ext>
             </a:extLst>
           </p:cNvPr>
@@ -5718,7 +5718,7 @@
           <p:cNvPr id="125" name="takeaway-cape-gradient-18">
             <a:extLst xmlns:a="http://schemas.openxmlformats.org/drawingml/2006/main">
               <a:ext uri="{FF2B5EF4-FFF2-40B4-BE49-F238E27FC236}">
-                <a16:creationId xmlns:a16="http://schemas.microsoft.com/office/drawing/2014/main" id="{40A1F4F4-AB49-4088-9AD9-FA11483719BC}"/>
+                <a16:creationId xmlns:a16="http://schemas.microsoft.com/office/drawing/2014/main" id="{6AA4CFCD-E8D8-459F-B133-28C885EFA835}"/>
               </a:ext>
             </a:extLst>
           </p:cNvPr>
@@ -5751,7 +5751,7 @@
           <p:cNvPr id="126" name="takeaway-cape-gradient-19">
             <a:extLst xmlns:a="http://schemas.openxmlformats.org/drawingml/2006/main">
               <a:ext uri="{FF2B5EF4-FFF2-40B4-BE49-F238E27FC236}">
-                <a16:creationId xmlns:a16="http://schemas.microsoft.com/office/drawing/2014/main" id="{50D18A84-A871-4B19-A89A-DC1487FDEAF7}"/>
+                <a16:creationId xmlns:a16="http://schemas.microsoft.com/office/drawing/2014/main" id="{AD20270A-2528-495E-A3F2-003D07287DB5}"/>
               </a:ext>
             </a:extLst>
           </p:cNvPr>
@@ -5784,7 +5784,7 @@
           <p:cNvPr id="127" name="takeaway-cape-gradient-20">
             <a:extLst xmlns:a="http://schemas.openxmlformats.org/drawingml/2006/main">
               <a:ext uri="{FF2B5EF4-FFF2-40B4-BE49-F238E27FC236}">
-                <a16:creationId xmlns:a16="http://schemas.microsoft.com/office/drawing/2014/main" id="{171F483A-3CD1-4EA5-A19D-B1EE6B7B592B}"/>
+                <a16:creationId xmlns:a16="http://schemas.microsoft.com/office/drawing/2014/main" id="{256704D3-0ADF-4336-8F94-A0BB183946C4}"/>
               </a:ext>
             </a:extLst>
           </p:cNvPr>
@@ -5817,7 +5817,7 @@
           <p:cNvPr id="128" name="takeaway-cape-gradient-21">
             <a:extLst xmlns:a="http://schemas.openxmlformats.org/drawingml/2006/main">
               <a:ext uri="{FF2B5EF4-FFF2-40B4-BE49-F238E27FC236}">
-                <a16:creationId xmlns:a16="http://schemas.microsoft.com/office/drawing/2014/main" id="{F87AF29F-848B-49C7-8AB2-47C9071BFF27}"/>
+                <a16:creationId xmlns:a16="http://schemas.microsoft.com/office/drawing/2014/main" id="{7559E327-DD47-4CC4-8694-A392E1CFCBB3}"/>
               </a:ext>
             </a:extLst>
           </p:cNvPr>
@@ -5850,7 +5850,7 @@
           <p:cNvPr id="129" name="takeaway-cape-gradient-22">
             <a:extLst xmlns:a="http://schemas.openxmlformats.org/drawingml/2006/main">
               <a:ext uri="{FF2B5EF4-FFF2-40B4-BE49-F238E27FC236}">
-                <a16:creationId xmlns:a16="http://schemas.microsoft.com/office/drawing/2014/main" id="{F6F9F065-055C-45CC-A27E-D7EEAE72A2DF}"/>
+                <a16:creationId xmlns:a16="http://schemas.microsoft.com/office/drawing/2014/main" id="{8A775B41-B421-45BB-BE42-72172829727B}"/>
               </a:ext>
             </a:extLst>
           </p:cNvPr>
@@ -5883,7 +5883,7 @@
           <p:cNvPr id="130" name="takeaway-cape-gradient-23">
             <a:extLst xmlns:a="http://schemas.openxmlformats.org/drawingml/2006/main">
               <a:ext uri="{FF2B5EF4-FFF2-40B4-BE49-F238E27FC236}">
-                <a16:creationId xmlns:a16="http://schemas.microsoft.com/office/drawing/2014/main" id="{F7F1CCED-BE9A-48BA-A927-8BEC9EF6D934}"/>
+                <a16:creationId xmlns:a16="http://schemas.microsoft.com/office/drawing/2014/main" id="{6A10FECD-23FC-4107-8C8E-20F1F120AC03}"/>
               </a:ext>
             </a:extLst>
           </p:cNvPr>
@@ -5916,7 +5916,7 @@
           <p:cNvPr id="131" name="takeaway-cape-gradient-24">
             <a:extLst xmlns:a="http://schemas.openxmlformats.org/drawingml/2006/main">
               <a:ext uri="{FF2B5EF4-FFF2-40B4-BE49-F238E27FC236}">
-                <a16:creationId xmlns:a16="http://schemas.microsoft.com/office/drawing/2014/main" id="{8339A974-3C07-416C-BB15-C7DF351D0202}"/>
+                <a16:creationId xmlns:a16="http://schemas.microsoft.com/office/drawing/2014/main" id="{E5AEFE61-1250-4447-B305-ECA9503AB58A}"/>
               </a:ext>
             </a:extLst>
           </p:cNvPr>
@@ -5949,7 +5949,7 @@
           <p:cNvPr id="132" name="takeaway-cape-gradient-25">
             <a:extLst xmlns:a="http://schemas.openxmlformats.org/drawingml/2006/main">
               <a:ext uri="{FF2B5EF4-FFF2-40B4-BE49-F238E27FC236}">
-                <a16:creationId xmlns:a16="http://schemas.microsoft.com/office/drawing/2014/main" id="{91E06424-4A34-4834-9373-50B8593128C5}"/>
+                <a16:creationId xmlns:a16="http://schemas.microsoft.com/office/drawing/2014/main" id="{8DD57706-75F2-4E00-8CC8-59E9EBEA5EA3}"/>
               </a:ext>
             </a:extLst>
           </p:cNvPr>
@@ -5982,7 +5982,7 @@
           <p:cNvPr id="133" name="takeaway-cape-gradient-26">
             <a:extLst xmlns:a="http://schemas.openxmlformats.org/drawingml/2006/main">
               <a:ext uri="{FF2B5EF4-FFF2-40B4-BE49-F238E27FC236}">
-                <a16:creationId xmlns:a16="http://schemas.microsoft.com/office/drawing/2014/main" id="{E120E055-FA0F-46ED-BF28-9FE1E1FBFF2D}"/>
+                <a16:creationId xmlns:a16="http://schemas.microsoft.com/office/drawing/2014/main" id="{BA0EDA94-DFC8-4206-A27B-F3134D55D820}"/>
               </a:ext>
             </a:extLst>
           </p:cNvPr>
@@ -6015,7 +6015,7 @@
           <p:cNvPr id="134" name="takeaway-cape-gradient-27">
             <a:extLst xmlns:a="http://schemas.openxmlformats.org/drawingml/2006/main">
               <a:ext uri="{FF2B5EF4-FFF2-40B4-BE49-F238E27FC236}">
-                <a16:creationId xmlns:a16="http://schemas.microsoft.com/office/drawing/2014/main" id="{D7C1475A-E6D1-46C9-8FD4-D30538F94057}"/>
+                <a16:creationId xmlns:a16="http://schemas.microsoft.com/office/drawing/2014/main" id="{366A7B42-009E-433F-8635-2EB656368075}"/>
               </a:ext>
             </a:extLst>
           </p:cNvPr>
@@ -6048,7 +6048,7 @@
           <p:cNvPr id="135" name="takeaway-cape-gradient-28">
             <a:extLst xmlns:a="http://schemas.openxmlformats.org/drawingml/2006/main">
               <a:ext uri="{FF2B5EF4-FFF2-40B4-BE49-F238E27FC236}">
-                <a16:creationId xmlns:a16="http://schemas.microsoft.com/office/drawing/2014/main" id="{6EBC00F3-3DF1-4824-A8EC-431B92778383}"/>
+                <a16:creationId xmlns:a16="http://schemas.microsoft.com/office/drawing/2014/main" id="{A4BE0E23-2F5B-4C47-83F7-2029E6201853}"/>
               </a:ext>
             </a:extLst>
           </p:cNvPr>
@@ -6081,7 +6081,7 @@
           <p:cNvPr id="136" name="takeaway-cape-gradient-29">
             <a:extLst xmlns:a="http://schemas.openxmlformats.org/drawingml/2006/main">
               <a:ext uri="{FF2B5EF4-FFF2-40B4-BE49-F238E27FC236}">
-                <a16:creationId xmlns:a16="http://schemas.microsoft.com/office/drawing/2014/main" id="{E0E1CD4B-320E-4057-93F2-B32530669D3F}"/>
+                <a16:creationId xmlns:a16="http://schemas.microsoft.com/office/drawing/2014/main" id="{EA97F98F-9078-4BED-A0D6-514BB23EB5F2}"/>
               </a:ext>
             </a:extLst>
           </p:cNvPr>
@@ -6114,7 +6114,7 @@
           <p:cNvPr id="137" name="takeaway-cape-gradient-30">
             <a:extLst xmlns:a="http://schemas.openxmlformats.org/drawingml/2006/main">
               <a:ext uri="{FF2B5EF4-FFF2-40B4-BE49-F238E27FC236}">
-                <a16:creationId xmlns:a16="http://schemas.microsoft.com/office/drawing/2014/main" id="{6E690075-E619-4C82-B682-3FE0013F8B5A}"/>
+                <a16:creationId xmlns:a16="http://schemas.microsoft.com/office/drawing/2014/main" id="{4B607ED9-58E7-4306-B12D-2C273B77D8D3}"/>
               </a:ext>
             </a:extLst>
           </p:cNvPr>
@@ -6147,7 +6147,7 @@
           <p:cNvPr id="138" name="takeaway-cape-gradient-31">
             <a:extLst xmlns:a="http://schemas.openxmlformats.org/drawingml/2006/main">
               <a:ext uri="{FF2B5EF4-FFF2-40B4-BE49-F238E27FC236}">
-                <a16:creationId xmlns:a16="http://schemas.microsoft.com/office/drawing/2014/main" id="{05550D2C-9882-4EFD-9656-179ACA54C25F}"/>
+                <a16:creationId xmlns:a16="http://schemas.microsoft.com/office/drawing/2014/main" id="{7143A536-A248-4176-B766-2424CCBDB300}"/>
               </a:ext>
             </a:extLst>
           </p:cNvPr>
@@ -6180,7 +6180,7 @@
           <p:cNvPr id="139" name="takeaway-cape-gradient-32">
             <a:extLst xmlns:a="http://schemas.openxmlformats.org/drawingml/2006/main">
               <a:ext uri="{FF2B5EF4-FFF2-40B4-BE49-F238E27FC236}">
-                <a16:creationId xmlns:a16="http://schemas.microsoft.com/office/drawing/2014/main" id="{9571B662-7D9E-4F66-A17C-676309F89D8E}"/>
+                <a16:creationId xmlns:a16="http://schemas.microsoft.com/office/drawing/2014/main" id="{5EE08D3D-2798-401C-B042-1C6F8560F252}"/>
               </a:ext>
             </a:extLst>
           </p:cNvPr>
@@ -6213,7 +6213,7 @@
           <p:cNvPr id="140" name="central-takeaway-title">
             <a:extLst xmlns:a="http://schemas.openxmlformats.org/drawingml/2006/main">
               <a:ext uri="{FF2B5EF4-FFF2-40B4-BE49-F238E27FC236}">
-                <a16:creationId xmlns:a16="http://schemas.microsoft.com/office/drawing/2014/main" id="{5C7A233F-BAAF-4B3F-B17B-B9A02B5BAA00}"/>
+                <a16:creationId xmlns:a16="http://schemas.microsoft.com/office/drawing/2014/main" id="{01C2C3E3-32B5-4906-9F58-EE57B82B468A}"/>
               </a:ext>
             </a:extLst>
           </p:cNvPr>
@@ -6263,7 +6263,7 @@
           <p:cNvPr id="141" name="central-takeaway-subtitle">
             <a:extLst xmlns:a="http://schemas.openxmlformats.org/drawingml/2006/main">
               <a:ext uri="{FF2B5EF4-FFF2-40B4-BE49-F238E27FC236}">
-                <a16:creationId xmlns:a16="http://schemas.microsoft.com/office/drawing/2014/main" id="{2C261DFA-C5AA-450B-AFD9-476B16304D06}"/>
+                <a16:creationId xmlns:a16="http://schemas.microsoft.com/office/drawing/2014/main" id="{B841B085-71C4-4150-BBCD-9249BCD2BBA0}"/>
               </a:ext>
             </a:extLst>
           </p:cNvPr>
@@ -6313,7 +6313,7 @@
           <p:cNvPr id="142" name="takeaway-evidence">
             <a:extLst xmlns:a="http://schemas.openxmlformats.org/drawingml/2006/main">
               <a:ext uri="{FF2B5EF4-FFF2-40B4-BE49-F238E27FC236}">
-                <a16:creationId xmlns:a16="http://schemas.microsoft.com/office/drawing/2014/main" id="{155BA4FF-906A-40D7-B02C-88F64E1D541D}"/>
+                <a16:creationId xmlns:a16="http://schemas.microsoft.com/office/drawing/2014/main" id="{16F83D67-C626-4501-A0D3-FB0C95862138}"/>
               </a:ext>
             </a:extLst>
           </p:cNvPr>
@@ -6363,7 +6363,7 @@
           <p:cNvPr id="143" name="figure-two-heading-title">
             <a:extLst xmlns:a="http://schemas.openxmlformats.org/drawingml/2006/main">
               <a:ext uri="{FF2B5EF4-FFF2-40B4-BE49-F238E27FC236}">
-                <a16:creationId xmlns:a16="http://schemas.microsoft.com/office/drawing/2014/main" id="{AE60EFC9-800F-4EB8-B95F-5065604F5C41}"/>
+                <a16:creationId xmlns:a16="http://schemas.microsoft.com/office/drawing/2014/main" id="{1C914D85-D189-430D-8A39-29B7BE219E58}"/>
               </a:ext>
             </a:extLst>
           </p:cNvPr>
@@ -6413,7 +6413,7 @@
           <p:cNvPr id="144" name="figure-two-heading-rule">
             <a:extLst xmlns:a="http://schemas.openxmlformats.org/drawingml/2006/main">
               <a:ext uri="{FF2B5EF4-FFF2-40B4-BE49-F238E27FC236}">
-                <a16:creationId xmlns:a16="http://schemas.microsoft.com/office/drawing/2014/main" id="{83A82E45-139F-437C-92D1-675B3B2EBC7A}"/>
+                <a16:creationId xmlns:a16="http://schemas.microsoft.com/office/drawing/2014/main" id="{DA698A3C-57F2-4E43-BEDD-9E529C571D0D}"/>
               </a:ext>
             </a:extLst>
           </p:cNvPr>
@@ -6446,7 +6446,7 @@
           <p:cNvPr id="145" name="figure-two-frame">
             <a:extLst xmlns:a="http://schemas.openxmlformats.org/drawingml/2006/main">
               <a:ext uri="{FF2B5EF4-FFF2-40B4-BE49-F238E27FC236}">
-                <a16:creationId xmlns:a16="http://schemas.microsoft.com/office/drawing/2014/main" id="{4CF373AF-15AA-495B-BD8C-8C555A32ECBF}"/>
+                <a16:creationId xmlns:a16="http://schemas.microsoft.com/office/drawing/2014/main" id="{2214F4AB-AC29-4260-8D49-15B9A8A0F785}"/>
               </a:ext>
             </a:extLst>
           </p:cNvPr>
@@ -6485,10 +6485,10 @@
           <p:nvPr/>
         </p:nvPicPr>
         <p:blipFill>
-          <a:blip xmlns:r="http://schemas.openxmlformats.org/officeDocument/2006/relationships" xmlns:a="http://schemas.openxmlformats.org/drawingml/2006/main" r:embed="Re3585a75ec3e42ef">
+          <a:blip xmlns:r="http://schemas.openxmlformats.org/officeDocument/2006/relationships" xmlns:a="http://schemas.openxmlformats.org/drawingml/2006/main" r:embed="R5328dfb7b357454f">
             <a:extLst>
               <a:ext uri="{96DAC541-7B7A-43D3-8B79-37D633B846F1}">
-                <asvg:svgBlip xmlns:asvg="http://schemas.microsoft.com/office/drawing/2016/SVG/main" r:embed="R7988a5ec379e48c1"/>
+                <asvg:svgBlip xmlns:asvg="http://schemas.microsoft.com/office/drawing/2016/SVG/main" r:embed="Rf141f24ab99145b1"/>
               </a:ext>
             </a:extLst>
           </a:blip>
@@ -6509,7 +6509,7 @@
           <p:cNvPr id="147" name="figure-two-caption">
             <a:extLst xmlns:a="http://schemas.openxmlformats.org/drawingml/2006/main">
               <a:ext uri="{FF2B5EF4-FFF2-40B4-BE49-F238E27FC236}">
-                <a16:creationId xmlns:a16="http://schemas.microsoft.com/office/drawing/2014/main" id="{E2FB0565-3095-444F-BE3B-EC36CA8B53C0}"/>
+                <a16:creationId xmlns:a16="http://schemas.microsoft.com/office/drawing/2014/main" id="{6CD16654-E8FB-4569-90D5-D81B3A8A56A5}"/>
               </a:ext>
             </a:extLst>
           </p:cNvPr>
@@ -6559,7 +6559,7 @@
           <p:cNvPr id="148" name="figure-two-source">
             <a:extLst xmlns:a="http://schemas.openxmlformats.org/drawingml/2006/main">
               <a:ext uri="{FF2B5EF4-FFF2-40B4-BE49-F238E27FC236}">
-                <a16:creationId xmlns:a16="http://schemas.microsoft.com/office/drawing/2014/main" id="{91352035-CD49-4AC9-8DF0-4CA2C1F5D733}"/>
+                <a16:creationId xmlns:a16="http://schemas.microsoft.com/office/drawing/2014/main" id="{10BCD05C-C684-4344-97AD-0CFAADB5BE8A}"/>
               </a:ext>
             </a:extLst>
           </p:cNvPr>
@@ -6609,7 +6609,7 @@
           <p:cNvPr id="149" name="validation-heading-title">
             <a:extLst xmlns:a="http://schemas.openxmlformats.org/drawingml/2006/main">
               <a:ext uri="{FF2B5EF4-FFF2-40B4-BE49-F238E27FC236}">
-                <a16:creationId xmlns:a16="http://schemas.microsoft.com/office/drawing/2014/main" id="{9F5385F5-9336-453E-9F6A-013F8686A833}"/>
+                <a16:creationId xmlns:a16="http://schemas.microsoft.com/office/drawing/2014/main" id="{92179E55-F4BF-42AB-B86B-D0A702C3AE19}"/>
               </a:ext>
             </a:extLst>
           </p:cNvPr>
@@ -6659,7 +6659,7 @@
           <p:cNvPr id="150" name="validation-heading-rule">
             <a:extLst xmlns:a="http://schemas.openxmlformats.org/drawingml/2006/main">
               <a:ext uri="{FF2B5EF4-FFF2-40B4-BE49-F238E27FC236}">
-                <a16:creationId xmlns:a16="http://schemas.microsoft.com/office/drawing/2014/main" id="{BE39415A-F2CB-479A-85A6-31B3B12C40FD}"/>
+                <a16:creationId xmlns:a16="http://schemas.microsoft.com/office/drawing/2014/main" id="{5DE31430-FE20-41D5-A29E-32F4FC2ABB55}"/>
               </a:ext>
             </a:extLst>
           </p:cNvPr>
@@ -6692,7 +6692,7 @@
           <p:cNvPr id="151" name="validation-panel">
             <a:extLst xmlns:a="http://schemas.openxmlformats.org/drawingml/2006/main">
               <a:ext uri="{FF2B5EF4-FFF2-40B4-BE49-F238E27FC236}">
-                <a16:creationId xmlns:a16="http://schemas.microsoft.com/office/drawing/2014/main" id="{60F48BFC-27AF-4155-850A-DEBAA6913077}"/>
+                <a16:creationId xmlns:a16="http://schemas.microsoft.com/office/drawing/2014/main" id="{B8F7A5D8-F8C3-49DA-9596-1E617532631A}"/>
               </a:ext>
             </a:extLst>
           </p:cNvPr>
@@ -6727,7 +6727,7 @@
           <p:cNvPr id="152" name="validation">
             <a:extLst xmlns:a="http://schemas.openxmlformats.org/drawingml/2006/main">
               <a:ext uri="{FF2B5EF4-FFF2-40B4-BE49-F238E27FC236}">
-                <a16:creationId xmlns:a16="http://schemas.microsoft.com/office/drawing/2014/main" id="{8B67E589-257B-4994-8020-0E8EDA336DBC}"/>
+                <a16:creationId xmlns:a16="http://schemas.microsoft.com/office/drawing/2014/main" id="{0BB92746-2B38-4CFE-B9D7-67EA3DFEFBF1}"/>
               </a:ext>
             </a:extLst>
           </p:cNvPr>
@@ -6828,7 +6828,7 @@
           <p:cNvPr id="153" name="validation-evidence">
             <a:extLst xmlns:a="http://schemas.openxmlformats.org/drawingml/2006/main">
               <a:ext uri="{FF2B5EF4-FFF2-40B4-BE49-F238E27FC236}">
-                <a16:creationId xmlns:a16="http://schemas.microsoft.com/office/drawing/2014/main" id="{5A19BFE3-F389-4C37-90C0-2F69E291275F}"/>
+                <a16:creationId xmlns:a16="http://schemas.microsoft.com/office/drawing/2014/main" id="{5C2404A2-FA97-4C42-8C01-3584F2833B3F}"/>
               </a:ext>
             </a:extLst>
           </p:cNvPr>
@@ -6878,7 +6878,7 @@
           <p:cNvPr id="154" name="performance-strip">
             <a:extLst xmlns:a="http://schemas.openxmlformats.org/drawingml/2006/main">
               <a:ext uri="{FF2B5EF4-FFF2-40B4-BE49-F238E27FC236}">
-                <a16:creationId xmlns:a16="http://schemas.microsoft.com/office/drawing/2014/main" id="{E6B24676-F695-4E5C-9890-5ABAE99425F6}"/>
+                <a16:creationId xmlns:a16="http://schemas.microsoft.com/office/drawing/2014/main" id="{59A740F3-D439-4F89-9A84-597E9E6E8C9C}"/>
               </a:ext>
             </a:extLst>
           </p:cNvPr>
@@ -6911,7 +6911,7 @@
           <p:cNvPr id="155" name="performance-strip-text">
             <a:extLst xmlns:a="http://schemas.openxmlformats.org/drawingml/2006/main">
               <a:ext uri="{FF2B5EF4-FFF2-40B4-BE49-F238E27FC236}">
-                <a16:creationId xmlns:a16="http://schemas.microsoft.com/office/drawing/2014/main" id="{08474570-D1CD-413D-B49C-014A5E5385E7}"/>
+                <a16:creationId xmlns:a16="http://schemas.microsoft.com/office/drawing/2014/main" id="{2CDDF371-95B0-453E-8883-BCEA8B5E8876}"/>
               </a:ext>
             </a:extLst>
           </p:cNvPr>
@@ -6961,7 +6961,7 @@
           <p:cNvPr id="156" name="biology-heading-title">
             <a:extLst xmlns:a="http://schemas.openxmlformats.org/drawingml/2006/main">
               <a:ext uri="{FF2B5EF4-FFF2-40B4-BE49-F238E27FC236}">
-                <a16:creationId xmlns:a16="http://schemas.microsoft.com/office/drawing/2014/main" id="{FA79540D-58B0-43AC-A3BF-B5A65D11E2B3}"/>
+                <a16:creationId xmlns:a16="http://schemas.microsoft.com/office/drawing/2014/main" id="{CF6FC7BF-28E5-476D-B4E7-E125ECBFD270}"/>
               </a:ext>
             </a:extLst>
           </p:cNvPr>
@@ -7011,7 +7011,7 @@
           <p:cNvPr id="157" name="biology-heading-rule">
             <a:extLst xmlns:a="http://schemas.openxmlformats.org/drawingml/2006/main">
               <a:ext uri="{FF2B5EF4-FFF2-40B4-BE49-F238E27FC236}">
-                <a16:creationId xmlns:a16="http://schemas.microsoft.com/office/drawing/2014/main" id="{B8F74E0F-4FEA-4557-BB62-5D21A6802005}"/>
+                <a16:creationId xmlns:a16="http://schemas.microsoft.com/office/drawing/2014/main" id="{13D380CC-2A51-4735-A6AE-D02A45654683}"/>
               </a:ext>
             </a:extLst>
           </p:cNvPr>
@@ -7044,7 +7044,7 @@
           <p:cNvPr id="158" name="biology-1-value">
             <a:extLst xmlns:a="http://schemas.openxmlformats.org/drawingml/2006/main">
               <a:ext uri="{FF2B5EF4-FFF2-40B4-BE49-F238E27FC236}">
-                <a16:creationId xmlns:a16="http://schemas.microsoft.com/office/drawing/2014/main" id="{DD386C8B-8F04-4A94-8408-F4AA70528C1B}"/>
+                <a16:creationId xmlns:a16="http://schemas.microsoft.com/office/drawing/2014/main" id="{D5B663FD-9DF2-46E0-A463-4BBBF1B681AF}"/>
               </a:ext>
             </a:extLst>
           </p:cNvPr>
@@ -7094,7 +7094,7 @@
           <p:cNvPr id="159" name="biology-1-label">
             <a:extLst xmlns:a="http://schemas.openxmlformats.org/drawingml/2006/main">
               <a:ext uri="{FF2B5EF4-FFF2-40B4-BE49-F238E27FC236}">
-                <a16:creationId xmlns:a16="http://schemas.microsoft.com/office/drawing/2014/main" id="{96FD8ACC-42AA-4A68-9638-3CB5BEAB0E90}"/>
+                <a16:creationId xmlns:a16="http://schemas.microsoft.com/office/drawing/2014/main" id="{87836DDC-A9CC-4B70-A60D-C9FDE2C4F8D8}"/>
               </a:ext>
             </a:extLst>
           </p:cNvPr>
@@ -7144,7 +7144,7 @@
           <p:cNvPr id="160" name="biology-2-value">
             <a:extLst xmlns:a="http://schemas.openxmlformats.org/drawingml/2006/main">
               <a:ext uri="{FF2B5EF4-FFF2-40B4-BE49-F238E27FC236}">
-                <a16:creationId xmlns:a16="http://schemas.microsoft.com/office/drawing/2014/main" id="{CBF3BE5F-D06E-48C7-A53D-1BC071C3119A}"/>
+                <a16:creationId xmlns:a16="http://schemas.microsoft.com/office/drawing/2014/main" id="{E599B866-7E23-42CD-A82E-93A70AEC782B}"/>
               </a:ext>
             </a:extLst>
           </p:cNvPr>
@@ -7172,14 +7172,14 @@
           <a:lstStyle xmlns:a="http://schemas.openxmlformats.org/drawingml/2006/main"/>
           <a:p xmlns:a="http://schemas.openxmlformats.org/drawingml/2006/main">
             <a:pPr>
-              <a:defRPr sz="5100" b="1">
+              <a:defRPr sz="4575" b="1">
                 <a:solidFill>
                   <a:srgbClr val="487AA1"/>
                 </a:solidFill>
               </a:defRPr>
             </a:pPr>
             <a:r>
-              <a:rPr sz="5100" b="1">
+              <a:rPr sz="4575" b="1">
                 <a:solidFill>
                   <a:srgbClr val="487AA1"/>
                 </a:solidFill>
@@ -7194,7 +7194,7 @@
           <p:cNvPr id="161" name="biology-2-label">
             <a:extLst xmlns:a="http://schemas.openxmlformats.org/drawingml/2006/main">
               <a:ext uri="{FF2B5EF4-FFF2-40B4-BE49-F238E27FC236}">
-                <a16:creationId xmlns:a16="http://schemas.microsoft.com/office/drawing/2014/main" id="{133AE209-C1E9-48F6-8109-82B29397C36A}"/>
+                <a16:creationId xmlns:a16="http://schemas.microsoft.com/office/drawing/2014/main" id="{CCC03D69-7A14-4AB1-B693-3EDC68645804}"/>
               </a:ext>
             </a:extLst>
           </p:cNvPr>
@@ -7244,7 +7244,7 @@
           <p:cNvPr id="162" name="biology-3-value">
             <a:extLst xmlns:a="http://schemas.openxmlformats.org/drawingml/2006/main">
               <a:ext uri="{FF2B5EF4-FFF2-40B4-BE49-F238E27FC236}">
-                <a16:creationId xmlns:a16="http://schemas.microsoft.com/office/drawing/2014/main" id="{FFD8454F-FDD2-4728-BD94-ADBDFDF564EB}"/>
+                <a16:creationId xmlns:a16="http://schemas.microsoft.com/office/drawing/2014/main" id="{C01940A4-502F-40D4-88AF-8142F6DC007B}"/>
               </a:ext>
             </a:extLst>
           </p:cNvPr>
@@ -7272,14 +7272,14 @@
           <a:lstStyle xmlns:a="http://schemas.openxmlformats.org/drawingml/2006/main"/>
           <a:p xmlns:a="http://schemas.openxmlformats.org/drawingml/2006/main">
             <a:pPr>
-              <a:defRPr sz="5100" b="1">
+              <a:defRPr sz="3900" b="1">
                 <a:solidFill>
                   <a:srgbClr val="E5BC6C"/>
                 </a:solidFill>
               </a:defRPr>
             </a:pPr>
             <a:r>
-              <a:rPr sz="5100" b="1">
+              <a:rPr sz="3900" b="1">
                 <a:solidFill>
                   <a:srgbClr val="E5BC6C"/>
                 </a:solidFill>
@@ -7294,7 +7294,7 @@
           <p:cNvPr id="163" name="biology-3-label">
             <a:extLst xmlns:a="http://schemas.openxmlformats.org/drawingml/2006/main">
               <a:ext uri="{FF2B5EF4-FFF2-40B4-BE49-F238E27FC236}">
-                <a16:creationId xmlns:a16="http://schemas.microsoft.com/office/drawing/2014/main" id="{A920086D-539B-4C03-A32C-6D782CEB088B}"/>
+                <a16:creationId xmlns:a16="http://schemas.microsoft.com/office/drawing/2014/main" id="{CBFCE9D9-6B24-4307-B247-590D6043A2F6}"/>
               </a:ext>
             </a:extLst>
           </p:cNvPr>
@@ -7344,7 +7344,7 @@
           <p:cNvPr id="164" name="biology-evidence">
             <a:extLst xmlns:a="http://schemas.openxmlformats.org/drawingml/2006/main">
               <a:ext uri="{FF2B5EF4-FFF2-40B4-BE49-F238E27FC236}">
-                <a16:creationId xmlns:a16="http://schemas.microsoft.com/office/drawing/2014/main" id="{90E0A10F-C7AD-45E9-8661-F0CFBE3C0C44}"/>
+                <a16:creationId xmlns:a16="http://schemas.microsoft.com/office/drawing/2014/main" id="{9CD73FFB-6C02-49E1-9006-2CC75B00B4CF}"/>
               </a:ext>
             </a:extLst>
           </p:cNvPr>
@@ -7394,7 +7394,7 @@
           <p:cNvPr id="165" name="figure-three-frame">
             <a:extLst xmlns:a="http://schemas.openxmlformats.org/drawingml/2006/main">
               <a:ext uri="{FF2B5EF4-FFF2-40B4-BE49-F238E27FC236}">
-                <a16:creationId xmlns:a16="http://schemas.microsoft.com/office/drawing/2014/main" id="{0B01A05D-D4E3-40A7-86E2-C9945870CA35}"/>
+                <a16:creationId xmlns:a16="http://schemas.microsoft.com/office/drawing/2014/main" id="{5A47A752-9014-4AB3-B048-9E155D3921F7}"/>
               </a:ext>
             </a:extLst>
           </p:cNvPr>
@@ -7433,10 +7433,10 @@
           <p:nvPr/>
         </p:nvPicPr>
         <p:blipFill>
-          <a:blip xmlns:r="http://schemas.openxmlformats.org/officeDocument/2006/relationships" xmlns:a="http://schemas.openxmlformats.org/drawingml/2006/main" r:embed="R3c9a99e38a7c4642">
+          <a:blip xmlns:r="http://schemas.openxmlformats.org/officeDocument/2006/relationships" xmlns:a="http://schemas.openxmlformats.org/drawingml/2006/main" r:embed="Rf70c5df4a6b94f48">
             <a:extLst>
               <a:ext uri="{96DAC541-7B7A-43D3-8B79-37D633B846F1}">
-                <asvg:svgBlip xmlns:asvg="http://schemas.microsoft.com/office/drawing/2016/SVG/main" r:embed="R6655df4625334c50"/>
+                <asvg:svgBlip xmlns:asvg="http://schemas.microsoft.com/office/drawing/2016/SVG/main" r:embed="R3f35bbc121a04b83"/>
               </a:ext>
             </a:extLst>
           </a:blip>
@@ -7457,7 +7457,7 @@
           <p:cNvPr id="167" name="figure-three-caption">
             <a:extLst xmlns:a="http://schemas.openxmlformats.org/drawingml/2006/main">
               <a:ext uri="{FF2B5EF4-FFF2-40B4-BE49-F238E27FC236}">
-                <a16:creationId xmlns:a16="http://schemas.microsoft.com/office/drawing/2014/main" id="{7E1DCF51-58C0-4D7D-8D9F-004EF5AB92F7}"/>
+                <a16:creationId xmlns:a16="http://schemas.microsoft.com/office/drawing/2014/main" id="{EBF2FADC-AECA-41D9-A907-5FCD9D5428D3}"/>
               </a:ext>
             </a:extLst>
           </p:cNvPr>
@@ -7507,7 +7507,7 @@
           <p:cNvPr id="168" name="figure-three-source">
             <a:extLst xmlns:a="http://schemas.openxmlformats.org/drawingml/2006/main">
               <a:ext uri="{FF2B5EF4-FFF2-40B4-BE49-F238E27FC236}">
-                <a16:creationId xmlns:a16="http://schemas.microsoft.com/office/drawing/2014/main" id="{485113A8-97C2-4BAB-A045-946F6EA9ACB6}"/>
+                <a16:creationId xmlns:a16="http://schemas.microsoft.com/office/drawing/2014/main" id="{C3FAE8BE-0FEA-43E9-ABA8-9BD90C9DF8FC}"/>
               </a:ext>
             </a:extLst>
           </p:cNvPr>
@@ -7557,7 +7557,7 @@
           <p:cNvPr id="169" name="validation-visual-heading-title">
             <a:extLst xmlns:a="http://schemas.openxmlformats.org/drawingml/2006/main">
               <a:ext uri="{FF2B5EF4-FFF2-40B4-BE49-F238E27FC236}">
-                <a16:creationId xmlns:a16="http://schemas.microsoft.com/office/drawing/2014/main" id="{08A78365-BAF2-4530-862B-D5326EDAECD8}"/>
+                <a16:creationId xmlns:a16="http://schemas.microsoft.com/office/drawing/2014/main" id="{C9621506-1BB6-45FB-A2D5-F1DEB987EAD6}"/>
               </a:ext>
             </a:extLst>
           </p:cNvPr>
@@ -7607,7 +7607,7 @@
           <p:cNvPr id="170" name="validation-visual-heading-rule">
             <a:extLst xmlns:a="http://schemas.openxmlformats.org/drawingml/2006/main">
               <a:ext uri="{FF2B5EF4-FFF2-40B4-BE49-F238E27FC236}">
-                <a16:creationId xmlns:a16="http://schemas.microsoft.com/office/drawing/2014/main" id="{6D376D75-4BDC-4FD7-AEAB-F0D9DF05A655}"/>
+                <a16:creationId xmlns:a16="http://schemas.microsoft.com/office/drawing/2014/main" id="{74A6D677-E124-4DAF-9141-17F7900D7251}"/>
               </a:ext>
             </a:extLst>
           </p:cNvPr>
@@ -7640,7 +7640,7 @@
           <p:cNvPr id="171" name="figure-four-frame">
             <a:extLst xmlns:a="http://schemas.openxmlformats.org/drawingml/2006/main">
               <a:ext uri="{FF2B5EF4-FFF2-40B4-BE49-F238E27FC236}">
-                <a16:creationId xmlns:a16="http://schemas.microsoft.com/office/drawing/2014/main" id="{2BEC978C-B2B4-48F1-804A-D26A0F3D2D4B}"/>
+                <a16:creationId xmlns:a16="http://schemas.microsoft.com/office/drawing/2014/main" id="{E72A3D60-8863-490F-AF1F-CCFF8727D363}"/>
               </a:ext>
             </a:extLst>
           </p:cNvPr>
@@ -7679,10 +7679,10 @@
           <p:nvPr/>
         </p:nvPicPr>
         <p:blipFill>
-          <a:blip xmlns:r="http://schemas.openxmlformats.org/officeDocument/2006/relationships" xmlns:a="http://schemas.openxmlformats.org/drawingml/2006/main" r:embed="R6086b1b6acc14aff">
+          <a:blip xmlns:r="http://schemas.openxmlformats.org/officeDocument/2006/relationships" xmlns:a="http://schemas.openxmlformats.org/drawingml/2006/main" r:embed="Rd0475bead5d7445a">
             <a:extLst>
               <a:ext uri="{96DAC541-7B7A-43D3-8B79-37D633B846F1}">
-                <asvg:svgBlip xmlns:asvg="http://schemas.microsoft.com/office/drawing/2016/SVG/main" r:embed="R3e4be5976b1541ef"/>
+                <asvg:svgBlip xmlns:asvg="http://schemas.microsoft.com/office/drawing/2016/SVG/main" r:embed="R24e520a63c7f4076"/>
               </a:ext>
             </a:extLst>
           </a:blip>
@@ -7703,7 +7703,7 @@
           <p:cNvPr id="173" name="figure-four-caption">
             <a:extLst xmlns:a="http://schemas.openxmlformats.org/drawingml/2006/main">
               <a:ext uri="{FF2B5EF4-FFF2-40B4-BE49-F238E27FC236}">
-                <a16:creationId xmlns:a16="http://schemas.microsoft.com/office/drawing/2014/main" id="{C7BD4317-5E4A-4CA0-8B18-435C24036D8A}"/>
+                <a16:creationId xmlns:a16="http://schemas.microsoft.com/office/drawing/2014/main" id="{4E24F9C1-EDDE-472C-80FD-E25C247627BD}"/>
               </a:ext>
             </a:extLst>
           </p:cNvPr>
@@ -7753,7 +7753,7 @@
           <p:cNvPr id="174" name="figure-four-source">
             <a:extLst xmlns:a="http://schemas.openxmlformats.org/drawingml/2006/main">
               <a:ext uri="{FF2B5EF4-FFF2-40B4-BE49-F238E27FC236}">
-                <a16:creationId xmlns:a16="http://schemas.microsoft.com/office/drawing/2014/main" id="{A766C20B-9516-41A5-A403-A66FC76BDC1C}"/>
+                <a16:creationId xmlns:a16="http://schemas.microsoft.com/office/drawing/2014/main" id="{8EAD3D30-7AF8-4A3C-A0D5-019E5512D0CC}"/>
               </a:ext>
             </a:extLst>
           </p:cNvPr>
@@ -7803,7 +7803,7 @@
           <p:cNvPr id="175" name="conclusion-heading-title">
             <a:extLst xmlns:a="http://schemas.openxmlformats.org/drawingml/2006/main">
               <a:ext uri="{FF2B5EF4-FFF2-40B4-BE49-F238E27FC236}">
-                <a16:creationId xmlns:a16="http://schemas.microsoft.com/office/drawing/2014/main" id="{831AB2B9-6E14-4E6E-8C68-1EC654FEC18F}"/>
+                <a16:creationId xmlns:a16="http://schemas.microsoft.com/office/drawing/2014/main" id="{C7DE2409-CAAF-4A34-B8DA-9F4D884D2B9D}"/>
               </a:ext>
             </a:extLst>
           </p:cNvPr>
@@ -7853,7 +7853,7 @@
           <p:cNvPr id="176" name="conclusion-heading-rule">
             <a:extLst xmlns:a="http://schemas.openxmlformats.org/drawingml/2006/main">
               <a:ext uri="{FF2B5EF4-FFF2-40B4-BE49-F238E27FC236}">
-                <a16:creationId xmlns:a16="http://schemas.microsoft.com/office/drawing/2014/main" id="{DC305F54-8DD2-4EE5-A60F-96BCE6AD18E5}"/>
+                <a16:creationId xmlns:a16="http://schemas.microsoft.com/office/drawing/2014/main" id="{9B4D4317-FAD3-4FF3-A390-4317ECFC2762}"/>
               </a:ext>
             </a:extLst>
           </p:cNvPr>
@@ -7886,7 +7886,7 @@
           <p:cNvPr id="177" name="conclusion-panel">
             <a:extLst xmlns:a="http://schemas.openxmlformats.org/drawingml/2006/main">
               <a:ext uri="{FF2B5EF4-FFF2-40B4-BE49-F238E27FC236}">
-                <a16:creationId xmlns:a16="http://schemas.microsoft.com/office/drawing/2014/main" id="{C8B71D4D-D068-49F5-ABD8-638E96ED0FF8}"/>
+                <a16:creationId xmlns:a16="http://schemas.microsoft.com/office/drawing/2014/main" id="{CC836B3A-47D0-4372-A551-B65FB9B14888}"/>
               </a:ext>
             </a:extLst>
           </p:cNvPr>
@@ -7921,7 +7921,7 @@
           <p:cNvPr id="178" name="conclusion">
             <a:extLst xmlns:a="http://schemas.openxmlformats.org/drawingml/2006/main">
               <a:ext uri="{FF2B5EF4-FFF2-40B4-BE49-F238E27FC236}">
-                <a16:creationId xmlns:a16="http://schemas.microsoft.com/office/drawing/2014/main" id="{C29E4E65-969C-4445-9CCE-C32DABD80B92}"/>
+                <a16:creationId xmlns:a16="http://schemas.microsoft.com/office/drawing/2014/main" id="{2CA7A6E6-767F-49EE-8CA1-835026051D5A}"/>
               </a:ext>
             </a:extLst>
           </p:cNvPr>
@@ -7971,7 +7971,7 @@
           <p:cNvPr id="179" name="conclusion-evidence">
             <a:extLst xmlns:a="http://schemas.openxmlformats.org/drawingml/2006/main">
               <a:ext uri="{FF2B5EF4-FFF2-40B4-BE49-F238E27FC236}">
-                <a16:creationId xmlns:a16="http://schemas.microsoft.com/office/drawing/2014/main" id="{65D87D2F-D76E-462E-9543-8E327A6EB454}"/>
+                <a16:creationId xmlns:a16="http://schemas.microsoft.com/office/drawing/2014/main" id="{144BBEFB-A225-4801-BD9E-1DF9926753F0}"/>
               </a:ext>
             </a:extLst>
           </p:cNvPr>
@@ -8021,7 +8021,7 @@
           <p:cNvPr id="180" name="footer-band">
             <a:extLst xmlns:a="http://schemas.openxmlformats.org/drawingml/2006/main">
               <a:ext uri="{FF2B5EF4-FFF2-40B4-BE49-F238E27FC236}">
-                <a16:creationId xmlns:a16="http://schemas.microsoft.com/office/drawing/2014/main" id="{5F0E9D3A-60CB-43F7-9E56-8B2039B1AD0F}"/>
+                <a16:creationId xmlns:a16="http://schemas.microsoft.com/office/drawing/2014/main" id="{F5248BC8-8221-4FBA-81C7-0BED0773584D}"/>
               </a:ext>
             </a:extLst>
           </p:cNvPr>
@@ -8054,7 +8054,7 @@
           <p:cNvPr id="181" name="footer-source">
             <a:extLst xmlns:a="http://schemas.openxmlformats.org/drawingml/2006/main">
               <a:ext uri="{FF2B5EF4-FFF2-40B4-BE49-F238E27FC236}">
-                <a16:creationId xmlns:a16="http://schemas.microsoft.com/office/drawing/2014/main" id="{7C649F33-E20A-4117-80CD-9313C5DEE8BD}"/>
+                <a16:creationId xmlns:a16="http://schemas.microsoft.com/office/drawing/2014/main" id="{A089EDCC-AD1E-410D-9286-CF5B57C627D2}"/>
               </a:ext>
             </a:extLst>
           </p:cNvPr>
@@ -8104,7 +8104,7 @@
           <p:cNvPr id="182" name="footer-status">
             <a:extLst xmlns:a="http://schemas.openxmlformats.org/drawingml/2006/main">
               <a:ext uri="{FF2B5EF4-FFF2-40B4-BE49-F238E27FC236}">
-                <a16:creationId xmlns:a16="http://schemas.microsoft.com/office/drawing/2014/main" id="{A0779615-D79F-416D-A374-DB95682E32A2}"/>
+                <a16:creationId xmlns:a16="http://schemas.microsoft.com/office/drawing/2014/main" id="{B7FF56B6-8A99-4FE7-8670-66C0C662E55B}"/>
               </a:ext>
             </a:extLst>
           </p:cNvPr>
@@ -8152,7 +8152,7 @@
     </p:spTree>
     <p:extLst>
       <p:ext uri="{BB962C8B-B14F-4D97-AF65-F5344CB8AC3E}">
-        <p14:creationId xmlns:p14="http://schemas.microsoft.com/office/powerpoint/2010/main" val="593814558"/>
+        <p14:creationId xmlns:p14="http://schemas.microsoft.com/office/powerpoint/2010/main" val="1664685486"/>
       </p:ext>
     </p:extLst>
   </p:cSld>

</xml_diff>